<commit_message>
slides: drop IAM/ECR/CloudWatch, focus core services + refocus recap on voice agent
- delete the Observability/security/container-supply slide (CloudWatch/IAM/ECR)
- slide 9: keep Bedrock/KB/AgentCore/S3/CloudFront/Lambda/Langfuse only
- slide 19 recap: 3 voice-agent pillars (speech-to-speech, tool calling + RAG,
  managed + observable)
- README: minor author-line edit

Co-Authored-By: Claude Opus 4.8 <noreply@anthropic.com>
</commit_message>
<xml_diff>
--- a/docs/slides/Hera-Voice-Agent-Sharing.pptx
+++ b/docs/slides/Hera-Voice-Agent-Sharing.pptx
@@ -321,7 +321,7 @@
           <a:p>
             <a:fld id="{5BCAD085-E8A6-8845-BD4E-CB4CCA059FC4}" type="datetimeFigureOut">
               <a:rPr lang="en-US" smtClean="0"/>
-              <a:t>5/28/2026</a:t>
+              <a:t>5/30/2026</a:t>
             </a:fld>
             <a:endParaRPr lang="en-US"/>
           </a:p>
@@ -489,7 +489,7 @@
           <a:p>
             <a:fld id="{5BCAD085-E8A6-8845-BD4E-CB4CCA059FC4}" type="datetimeFigureOut">
               <a:rPr lang="en-US" smtClean="0"/>
-              <a:t>5/28/2026</a:t>
+              <a:t>5/30/2026</a:t>
             </a:fld>
             <a:endParaRPr lang="en-US"/>
           </a:p>
@@ -667,7 +667,7 @@
           <a:p>
             <a:fld id="{5BCAD085-E8A6-8845-BD4E-CB4CCA059FC4}" type="datetimeFigureOut">
               <a:rPr lang="en-US" smtClean="0"/>
-              <a:t>5/28/2026</a:t>
+              <a:t>5/30/2026</a:t>
             </a:fld>
             <a:endParaRPr lang="en-US"/>
           </a:p>
@@ -835,7 +835,7 @@
           <a:p>
             <a:fld id="{5BCAD085-E8A6-8845-BD4E-CB4CCA059FC4}" type="datetimeFigureOut">
               <a:rPr lang="en-US" smtClean="0"/>
-              <a:t>5/28/2026</a:t>
+              <a:t>5/30/2026</a:t>
             </a:fld>
             <a:endParaRPr lang="en-US"/>
           </a:p>
@@ -1080,7 +1080,7 @@
           <a:p>
             <a:fld id="{5BCAD085-E8A6-8845-BD4E-CB4CCA059FC4}" type="datetimeFigureOut">
               <a:rPr lang="en-US" smtClean="0"/>
-              <a:t>5/28/2026</a:t>
+              <a:t>5/30/2026</a:t>
             </a:fld>
             <a:endParaRPr lang="en-US"/>
           </a:p>
@@ -1365,7 +1365,7 @@
           <a:p>
             <a:fld id="{5BCAD085-E8A6-8845-BD4E-CB4CCA059FC4}" type="datetimeFigureOut">
               <a:rPr lang="en-US" smtClean="0"/>
-              <a:t>5/28/2026</a:t>
+              <a:t>5/30/2026</a:t>
             </a:fld>
             <a:endParaRPr lang="en-US"/>
           </a:p>
@@ -1784,7 +1784,7 @@
           <a:p>
             <a:fld id="{5BCAD085-E8A6-8845-BD4E-CB4CCA059FC4}" type="datetimeFigureOut">
               <a:rPr lang="en-US" smtClean="0"/>
-              <a:t>5/28/2026</a:t>
+              <a:t>5/30/2026</a:t>
             </a:fld>
             <a:endParaRPr lang="en-US"/>
           </a:p>
@@ -1901,7 +1901,7 @@
           <a:p>
             <a:fld id="{5BCAD085-E8A6-8845-BD4E-CB4CCA059FC4}" type="datetimeFigureOut">
               <a:rPr lang="en-US" smtClean="0"/>
-              <a:t>5/28/2026</a:t>
+              <a:t>5/30/2026</a:t>
             </a:fld>
             <a:endParaRPr lang="en-US"/>
           </a:p>
@@ -1996,7 +1996,7 @@
           <a:p>
             <a:fld id="{5BCAD085-E8A6-8845-BD4E-CB4CCA059FC4}" type="datetimeFigureOut">
               <a:rPr lang="en-US" smtClean="0"/>
-              <a:t>5/28/2026</a:t>
+              <a:t>5/30/2026</a:t>
             </a:fld>
             <a:endParaRPr lang="en-US"/>
           </a:p>
@@ -2271,7 +2271,7 @@
           <a:p>
             <a:fld id="{5BCAD085-E8A6-8845-BD4E-CB4CCA059FC4}" type="datetimeFigureOut">
               <a:rPr lang="en-US" smtClean="0"/>
-              <a:t>5/28/2026</a:t>
+              <a:t>5/30/2026</a:t>
             </a:fld>
             <a:endParaRPr lang="en-US"/>
           </a:p>
@@ -2523,7 +2523,7 @@
           <a:p>
             <a:fld id="{5BCAD085-E8A6-8845-BD4E-CB4CCA059FC4}" type="datetimeFigureOut">
               <a:rPr lang="en-US" smtClean="0"/>
-              <a:t>5/28/2026</a:t>
+              <a:t>5/30/2026</a:t>
             </a:fld>
             <a:endParaRPr lang="en-US"/>
           </a:p>
@@ -2734,7 +2734,7 @@
           <a:p>
             <a:fld id="{5BCAD085-E8A6-8845-BD4E-CB4CCA059FC4}" type="datetimeFigureOut">
               <a:rPr lang="en-US" smtClean="0"/>
-              <a:t>5/28/2026</a:t>
+              <a:t>5/30/2026</a:t>
             </a:fld>
             <a:endParaRPr lang="en-US"/>
           </a:p>
@@ -11228,8 +11228,8 @@
         </p:nvSpPr>
         <p:spPr>
           <a:xfrm>
-            <a:off x="640080" y="365760"/>
-            <a:ext cx="11247120" cy="731520"/>
+            <a:off x="640080" y="466479"/>
+            <a:ext cx="11247120" cy="530082"/>
           </a:xfrm>
           <a:prstGeom prst="rect">
             <a:avLst/>
@@ -11292,33 +11292,12 @@
               </a:rPr>
               <a:t>rộng</a:t>
             </a:r>
-            <a:r>
-              <a:rPr sz="3200" b="1" dirty="0">
-                <a:solidFill>
-                  <a:srgbClr val="FFFFFF"/>
-                </a:solidFill>
-                <a:latin typeface="Trebuchet MS"/>
-              </a:rPr>
-              <a:t> (v2 + </a:t>
-            </a:r>
-            <a:r>
-              <a:rPr sz="3200" b="1" dirty="0" err="1">
-                <a:solidFill>
-                  <a:srgbClr val="FFFFFF"/>
-                </a:solidFill>
-                <a:latin typeface="Trebuchet MS"/>
-              </a:rPr>
-              <a:t>sau</a:t>
-            </a:r>
-            <a:r>
-              <a:rPr sz="3200" b="1" dirty="0">
-                <a:solidFill>
-                  <a:srgbClr val="FFFFFF"/>
-                </a:solidFill>
-                <a:latin typeface="Trebuchet MS"/>
-              </a:rPr>
-              <a:t>)</a:t>
-            </a:r>
+            <a:endParaRPr sz="3200" b="1" dirty="0">
+              <a:solidFill>
+                <a:srgbClr val="FFFFFF"/>
+              </a:solidFill>
+              <a:latin typeface="Trebuchet MS"/>
+            </a:endParaRPr>
           </a:p>
         </p:txBody>
       </p:sp>
@@ -11350,14 +11329,146 @@
               </a:lnSpc>
             </a:pPr>
             <a:r>
-              <a:rPr sz="1400" b="0">
+              <a:rPr sz="1400" b="0" dirty="0" err="1">
                 <a:solidFill>
                   <a:srgbClr val="97A6BA"/>
                 </a:solidFill>
                 <a:latin typeface="Arial"/>
               </a:rPr>
-              <a:t>Tại sao giữ v1 và hướng mở rộng tiếp</a:t>
-            </a:r>
+              <a:t>Tại</a:t>
+            </a:r>
+            <a:r>
+              <a:rPr sz="1400" b="0" dirty="0">
+                <a:solidFill>
+                  <a:srgbClr val="97A6BA"/>
+                </a:solidFill>
+                <a:latin typeface="Arial"/>
+              </a:rPr>
+              <a:t> </a:t>
+            </a:r>
+            <a:r>
+              <a:rPr sz="1400" b="0" dirty="0" err="1">
+                <a:solidFill>
+                  <a:srgbClr val="97A6BA"/>
+                </a:solidFill>
+                <a:latin typeface="Arial"/>
+              </a:rPr>
+              <a:t>sao</a:t>
+            </a:r>
+            <a:r>
+              <a:rPr sz="1400" b="0" dirty="0">
+                <a:solidFill>
+                  <a:srgbClr val="97A6BA"/>
+                </a:solidFill>
+                <a:latin typeface="Arial"/>
+              </a:rPr>
+              <a:t> </a:t>
+            </a:r>
+            <a:r>
+              <a:rPr sz="1400" b="0" dirty="0" err="1">
+                <a:solidFill>
+                  <a:srgbClr val="97A6BA"/>
+                </a:solidFill>
+                <a:latin typeface="Arial"/>
+              </a:rPr>
+              <a:t>giữ</a:t>
+            </a:r>
+            <a:r>
+              <a:rPr sz="1400" b="0" dirty="0">
+                <a:solidFill>
+                  <a:srgbClr val="97A6BA"/>
+                </a:solidFill>
+                <a:latin typeface="Arial"/>
+              </a:rPr>
+              <a:t> v1 </a:t>
+            </a:r>
+            <a:r>
+              <a:rPr sz="1400" b="0" dirty="0" err="1">
+                <a:solidFill>
+                  <a:srgbClr val="97A6BA"/>
+                </a:solidFill>
+                <a:latin typeface="Arial"/>
+              </a:rPr>
+              <a:t>và</a:t>
+            </a:r>
+            <a:r>
+              <a:rPr sz="1400" b="0" dirty="0">
+                <a:solidFill>
+                  <a:srgbClr val="97A6BA"/>
+                </a:solidFill>
+                <a:latin typeface="Arial"/>
+              </a:rPr>
+              <a:t> </a:t>
+            </a:r>
+            <a:r>
+              <a:rPr sz="1400" b="0" dirty="0" err="1">
+                <a:solidFill>
+                  <a:srgbClr val="97A6BA"/>
+                </a:solidFill>
+                <a:latin typeface="Arial"/>
+              </a:rPr>
+              <a:t>hướng</a:t>
+            </a:r>
+            <a:r>
+              <a:rPr sz="1400" b="0" dirty="0">
+                <a:solidFill>
+                  <a:srgbClr val="97A6BA"/>
+                </a:solidFill>
+                <a:latin typeface="Arial"/>
+              </a:rPr>
+              <a:t> </a:t>
+            </a:r>
+            <a:r>
+              <a:rPr sz="1400" b="0" dirty="0" err="1">
+                <a:solidFill>
+                  <a:srgbClr val="97A6BA"/>
+                </a:solidFill>
+                <a:latin typeface="Arial"/>
+              </a:rPr>
+              <a:t>mở</a:t>
+            </a:r>
+            <a:r>
+              <a:rPr sz="1400" b="0" dirty="0">
+                <a:solidFill>
+                  <a:srgbClr val="97A6BA"/>
+                </a:solidFill>
+                <a:latin typeface="Arial"/>
+              </a:rPr>
+              <a:t> </a:t>
+            </a:r>
+            <a:r>
+              <a:rPr sz="1400" b="0" dirty="0" err="1">
+                <a:solidFill>
+                  <a:srgbClr val="97A6BA"/>
+                </a:solidFill>
+                <a:latin typeface="Arial"/>
+              </a:rPr>
+              <a:t>rộng</a:t>
+            </a:r>
+            <a:r>
+              <a:rPr sz="1400" b="0" dirty="0">
+                <a:solidFill>
+                  <a:srgbClr val="97A6BA"/>
+                </a:solidFill>
+                <a:latin typeface="Arial"/>
+              </a:rPr>
+              <a:t> </a:t>
+            </a:r>
+            <a:r>
+              <a:rPr sz="1400" b="0" dirty="0" err="1">
+                <a:solidFill>
+                  <a:srgbClr val="97A6BA"/>
+                </a:solidFill>
+                <a:latin typeface="Arial"/>
+              </a:rPr>
+              <a:t>tiếp</a:t>
+            </a:r>
+            <a:endParaRPr sz="1400" b="0" dirty="0">
+              <a:solidFill>
+                <a:srgbClr val="97A6BA"/>
+              </a:solidFill>
+              <a:latin typeface="Arial"/>
+            </a:endParaRPr>
           </a:p>
         </p:txBody>
       </p:sp>
@@ -13865,7 +13976,7 @@
         <p:spPr>
           <a:xfrm>
             <a:off x="1645920" y="3246120"/>
-            <a:ext cx="4114800" cy="365760"/>
+            <a:ext cx="4114800" cy="298159"/>
           </a:xfrm>
           <a:prstGeom prst="rect">
             <a:avLst/>
@@ -13890,34 +14001,170 @@
                 </a:solidFill>
                 <a:latin typeface="Trebuchet MS"/>
               </a:rPr>
-              <a:t>Demo + </a:t>
-            </a:r>
-            <a:r>
-              <a:rPr sz="1800" b="1" dirty="0" err="1">
+              <a:t>Demo</a:t>
+            </a:r>
+          </a:p>
+        </p:txBody>
+      </p:sp>
+      <p:sp>
+        <p:nvSpPr>
+          <p:cNvPr id="17" name="TextBox 16"/>
+          <p:cNvSpPr txBox="1"/>
+          <p:nvPr/>
+        </p:nvSpPr>
+        <p:spPr>
+          <a:xfrm>
+            <a:off x="1645920" y="3557016"/>
+            <a:ext cx="10058400" cy="292608"/>
+          </a:xfrm>
+          <a:prstGeom prst="rect">
+            <a:avLst/>
+          </a:prstGeom>
+          <a:noFill/>
+        </p:spPr>
+        <p:txBody>
+          <a:bodyPr wrap="square" lIns="0" tIns="0" rIns="0" bIns="0" anchor="t">
+            <a:spAutoFit/>
+          </a:bodyPr>
+          <a:lstStyle/>
+          <a:p>
+            <a:pPr algn="l">
+              <a:lnSpc>
+                <a:spcPct val="115000"/>
+              </a:lnSpc>
+            </a:pPr>
+            <a:r>
+              <a:rPr sz="1200" b="0">
+                <a:solidFill>
+                  <a:srgbClr val="97A6BA"/>
+                </a:solidFill>
+                <a:latin typeface="Arial"/>
+              </a:rPr>
+              <a:t>Voice loop live, cost, latency</a:t>
+            </a:r>
+          </a:p>
+        </p:txBody>
+      </p:sp>
+      <p:sp>
+        <p:nvSpPr>
+          <p:cNvPr id="18" name="Rounded Rectangle 17"/>
+          <p:cNvSpPr/>
+          <p:nvPr/>
+        </p:nvSpPr>
+        <p:spPr>
+          <a:xfrm>
+            <a:off x="777240" y="3922776"/>
+            <a:ext cx="640080" cy="594360"/>
+          </a:xfrm>
+          <a:prstGeom prst="roundRect">
+            <a:avLst>
+              <a:gd name="adj" fmla="val 5000"/>
+            </a:avLst>
+          </a:prstGeom>
+          <a:solidFill>
+            <a:srgbClr val="1C2A42"/>
+          </a:solidFill>
+          <a:ln>
+            <a:noFill/>
+          </a:ln>
+        </p:spPr>
+        <p:style>
+          <a:lnRef idx="1">
+            <a:schemeClr val="accent1"/>
+          </a:lnRef>
+          <a:fillRef idx="3">
+            <a:schemeClr val="accent1"/>
+          </a:fillRef>
+          <a:effectRef idx="2">
+            <a:schemeClr val="accent1"/>
+          </a:effectRef>
+          <a:fontRef idx="minor">
+            <a:schemeClr val="lt1"/>
+          </a:fontRef>
+        </p:style>
+        <p:txBody>
+          <a:bodyPr rtlCol="0" anchor="ctr"/>
+          <a:lstStyle/>
+          <a:p>
+            <a:pPr algn="ctr"/>
+            <a:endParaRPr/>
+          </a:p>
+        </p:txBody>
+      </p:sp>
+      <p:sp>
+        <p:nvSpPr>
+          <p:cNvPr id="19" name="TextBox 18"/>
+          <p:cNvSpPr txBox="1"/>
+          <p:nvPr/>
+        </p:nvSpPr>
+        <p:spPr>
+          <a:xfrm>
+            <a:off x="777240" y="3922776"/>
+            <a:ext cx="640080" cy="594360"/>
+          </a:xfrm>
+          <a:prstGeom prst="rect">
+            <a:avLst/>
+          </a:prstGeom>
+          <a:noFill/>
+        </p:spPr>
+        <p:txBody>
+          <a:bodyPr wrap="square" lIns="0" tIns="0" rIns="0" bIns="0" anchor="ctr">
+            <a:spAutoFit/>
+          </a:bodyPr>
+          <a:lstStyle/>
+          <a:p>
+            <a:pPr algn="ctr">
+              <a:lnSpc>
+                <a:spcPct val="115000"/>
+              </a:lnSpc>
+            </a:pPr>
+            <a:r>
+              <a:rPr sz="2000" b="1">
+                <a:solidFill>
+                  <a:srgbClr val="42B4FF"/>
+                </a:solidFill>
+                <a:latin typeface="Trebuchet MS"/>
+              </a:rPr>
+              <a:t>04</a:t>
+            </a:r>
+          </a:p>
+        </p:txBody>
+      </p:sp>
+      <p:sp>
+        <p:nvSpPr>
+          <p:cNvPr id="20" name="TextBox 19"/>
+          <p:cNvSpPr txBox="1"/>
+          <p:nvPr/>
+        </p:nvSpPr>
+        <p:spPr>
+          <a:xfrm>
+            <a:off x="1645920" y="3959352"/>
+            <a:ext cx="4114800" cy="298159"/>
+          </a:xfrm>
+          <a:prstGeom prst="rect">
+            <a:avLst/>
+          </a:prstGeom>
+          <a:noFill/>
+        </p:spPr>
+        <p:txBody>
+          <a:bodyPr wrap="square" lIns="0" tIns="0" rIns="0" bIns="0" anchor="t">
+            <a:spAutoFit/>
+          </a:bodyPr>
+          <a:lstStyle/>
+          <a:p>
+            <a:pPr algn="l">
+              <a:lnSpc>
+                <a:spcPct val="115000"/>
+              </a:lnSpc>
+            </a:pPr>
+            <a:r>
+              <a:rPr lang="en-US" b="1" dirty="0">
                 <a:solidFill>
                   <a:srgbClr val="FFFFFF"/>
                 </a:solidFill>
                 <a:latin typeface="Trebuchet MS"/>
               </a:rPr>
-              <a:t>số</a:t>
-            </a:r>
-            <a:r>
-              <a:rPr sz="1800" b="1" dirty="0">
-                <a:solidFill>
-                  <a:srgbClr val="FFFFFF"/>
-                </a:solidFill>
-                <a:latin typeface="Trebuchet MS"/>
-              </a:rPr>
-              <a:t> </a:t>
-            </a:r>
-            <a:r>
-              <a:rPr sz="1800" b="1" dirty="0" err="1">
-                <a:solidFill>
-                  <a:srgbClr val="FFFFFF"/>
-                </a:solidFill>
-                <a:latin typeface="Trebuchet MS"/>
-              </a:rPr>
-              <a:t>liệu</a:t>
+              <a:t>Recap</a:t>
             </a:r>
             <a:endParaRPr sz="1800" b="1" dirty="0">
               <a:solidFill>
@@ -13925,196 +14172,6 @@
               </a:solidFill>
               <a:latin typeface="Trebuchet MS"/>
             </a:endParaRPr>
-          </a:p>
-        </p:txBody>
-      </p:sp>
-      <p:sp>
-        <p:nvSpPr>
-          <p:cNvPr id="17" name="TextBox 16"/>
-          <p:cNvSpPr txBox="1"/>
-          <p:nvPr/>
-        </p:nvSpPr>
-        <p:spPr>
-          <a:xfrm>
-            <a:off x="1645920" y="3557016"/>
-            <a:ext cx="10058400" cy="292608"/>
-          </a:xfrm>
-          <a:prstGeom prst="rect">
-            <a:avLst/>
-          </a:prstGeom>
-          <a:noFill/>
-        </p:spPr>
-        <p:txBody>
-          <a:bodyPr wrap="square" lIns="0" tIns="0" rIns="0" bIns="0" anchor="t">
-            <a:spAutoFit/>
-          </a:bodyPr>
-          <a:lstStyle/>
-          <a:p>
-            <a:pPr algn="l">
-              <a:lnSpc>
-                <a:spcPct val="115000"/>
-              </a:lnSpc>
-            </a:pPr>
-            <a:r>
-              <a:rPr sz="1200" b="0">
-                <a:solidFill>
-                  <a:srgbClr val="97A6BA"/>
-                </a:solidFill>
-                <a:latin typeface="Arial"/>
-              </a:rPr>
-              <a:t>Voice loop live, cost, latency</a:t>
-            </a:r>
-          </a:p>
-        </p:txBody>
-      </p:sp>
-      <p:sp>
-        <p:nvSpPr>
-          <p:cNvPr id="18" name="Rounded Rectangle 17"/>
-          <p:cNvSpPr/>
-          <p:nvPr/>
-        </p:nvSpPr>
-        <p:spPr>
-          <a:xfrm>
-            <a:off x="777240" y="3922776"/>
-            <a:ext cx="640080" cy="594360"/>
-          </a:xfrm>
-          <a:prstGeom prst="roundRect">
-            <a:avLst>
-              <a:gd name="adj" fmla="val 5000"/>
-            </a:avLst>
-          </a:prstGeom>
-          <a:solidFill>
-            <a:srgbClr val="1C2A42"/>
-          </a:solidFill>
-          <a:ln>
-            <a:noFill/>
-          </a:ln>
-        </p:spPr>
-        <p:style>
-          <a:lnRef idx="1">
-            <a:schemeClr val="accent1"/>
-          </a:lnRef>
-          <a:fillRef idx="3">
-            <a:schemeClr val="accent1"/>
-          </a:fillRef>
-          <a:effectRef idx="2">
-            <a:schemeClr val="accent1"/>
-          </a:effectRef>
-          <a:fontRef idx="minor">
-            <a:schemeClr val="lt1"/>
-          </a:fontRef>
-        </p:style>
-        <p:txBody>
-          <a:bodyPr rtlCol="0" anchor="ctr"/>
-          <a:lstStyle/>
-          <a:p>
-            <a:pPr algn="ctr"/>
-            <a:endParaRPr/>
-          </a:p>
-        </p:txBody>
-      </p:sp>
-      <p:sp>
-        <p:nvSpPr>
-          <p:cNvPr id="19" name="TextBox 18"/>
-          <p:cNvSpPr txBox="1"/>
-          <p:nvPr/>
-        </p:nvSpPr>
-        <p:spPr>
-          <a:xfrm>
-            <a:off x="777240" y="3922776"/>
-            <a:ext cx="640080" cy="594360"/>
-          </a:xfrm>
-          <a:prstGeom prst="rect">
-            <a:avLst/>
-          </a:prstGeom>
-          <a:noFill/>
-        </p:spPr>
-        <p:txBody>
-          <a:bodyPr wrap="square" lIns="0" tIns="0" rIns="0" bIns="0" anchor="ctr">
-            <a:spAutoFit/>
-          </a:bodyPr>
-          <a:lstStyle/>
-          <a:p>
-            <a:pPr algn="ctr">
-              <a:lnSpc>
-                <a:spcPct val="115000"/>
-              </a:lnSpc>
-            </a:pPr>
-            <a:r>
-              <a:rPr sz="2000" b="1">
-                <a:solidFill>
-                  <a:srgbClr val="42B4FF"/>
-                </a:solidFill>
-                <a:latin typeface="Trebuchet MS"/>
-              </a:rPr>
-              <a:t>04</a:t>
-            </a:r>
-          </a:p>
-        </p:txBody>
-      </p:sp>
-      <p:sp>
-        <p:nvSpPr>
-          <p:cNvPr id="20" name="TextBox 19"/>
-          <p:cNvSpPr txBox="1"/>
-          <p:nvPr/>
-        </p:nvSpPr>
-        <p:spPr>
-          <a:xfrm>
-            <a:off x="1645920" y="3959352"/>
-            <a:ext cx="4114800" cy="365760"/>
-          </a:xfrm>
-          <a:prstGeom prst="rect">
-            <a:avLst/>
-          </a:prstGeom>
-          <a:noFill/>
-        </p:spPr>
-        <p:txBody>
-          <a:bodyPr wrap="square" lIns="0" tIns="0" rIns="0" bIns="0" anchor="t">
-            <a:spAutoFit/>
-          </a:bodyPr>
-          <a:lstStyle/>
-          <a:p>
-            <a:pPr algn="l">
-              <a:lnSpc>
-                <a:spcPct val="115000"/>
-              </a:lnSpc>
-            </a:pPr>
-            <a:r>
-              <a:rPr sz="1800" b="1" dirty="0" err="1">
-                <a:solidFill>
-                  <a:srgbClr val="FFFFFF"/>
-                </a:solidFill>
-                <a:latin typeface="Trebuchet MS"/>
-              </a:rPr>
-              <a:t>Bài</a:t>
-            </a:r>
-            <a:r>
-              <a:rPr sz="1800" b="1" dirty="0">
-                <a:solidFill>
-                  <a:srgbClr val="FFFFFF"/>
-                </a:solidFill>
-                <a:latin typeface="Trebuchet MS"/>
-              </a:rPr>
-              <a:t> </a:t>
-            </a:r>
-            <a:r>
-              <a:rPr sz="1800" b="1" dirty="0" err="1">
-                <a:solidFill>
-                  <a:srgbClr val="FFFFFF"/>
-                </a:solidFill>
-                <a:latin typeface="Trebuchet MS"/>
-              </a:rPr>
-              <a:t>học</a:t>
-            </a:r>
-            <a:r>
-              <a:rPr sz="1800" b="1" dirty="0">
-                <a:solidFill>
-                  <a:srgbClr val="FFFFFF"/>
-                </a:solidFill>
-                <a:latin typeface="Trebuchet MS"/>
-              </a:rPr>
-              <a:t> + v2</a:t>
-            </a:r>
           </a:p>
         </p:txBody>
       </p:sp>

</xml_diff>

<commit_message>
slides: remove IAM/ECR/CloudWatch tiles from the services overview slide
They were TextBox+icon (not card groups) so the earlier pass missed them.
Now removed (label + description + nearest icon) -> services slide focuses on
Bedrock / KB+S3 Vectors / AgentCore / S3 / CloudFront / Lambda + Langfuse (chip).

Co-Authored-By: Claude Opus 4.8 <noreply@anthropic.com>
</commit_message>
<xml_diff>
--- a/docs/slides/Hera-Voice-Agent-Sharing.pptx
+++ b/docs/slides/Hera-Voice-Agent-Sharing.pptx
@@ -18527,84 +18527,6 @@
       </p:pic>
       <p:sp>
         <p:nvSpPr>
-          <p:cNvPr id="32" name="TextBox 31"/>
-          <p:cNvSpPr txBox="1"/>
-          <p:nvPr/>
-        </p:nvSpPr>
-        <p:spPr>
-          <a:xfrm>
-            <a:off x="1828800" y="4910328"/>
-            <a:ext cx="2331720" cy="457200"/>
-          </a:xfrm>
-          <a:prstGeom prst="rect">
-            <a:avLst/>
-          </a:prstGeom>
-          <a:noFill/>
-        </p:spPr>
-        <p:txBody>
-          <a:bodyPr wrap="square" lIns="0" tIns="0" rIns="0" bIns="0" anchor="t">
-            <a:spAutoFit/>
-          </a:bodyPr>
-          <a:lstStyle/>
-          <a:p>
-            <a:pPr algn="l">
-              <a:lnSpc>
-                <a:spcPct val="115000"/>
-              </a:lnSpc>
-            </a:pPr>
-            <a:r>
-              <a:rPr sz="1600" b="1">
-                <a:solidFill>
-                  <a:srgbClr val="FFFFFF"/>
-                </a:solidFill>
-                <a:latin typeface="Trebuchet MS"/>
-              </a:rPr>
-              <a:t>ECR</a:t>
-            </a:r>
-          </a:p>
-        </p:txBody>
-      </p:sp>
-      <p:sp>
-        <p:nvSpPr>
-          <p:cNvPr id="33" name="TextBox 32"/>
-          <p:cNvSpPr txBox="1"/>
-          <p:nvPr/>
-        </p:nvSpPr>
-        <p:spPr>
-          <a:xfrm>
-            <a:off x="1828800" y="5367528"/>
-            <a:ext cx="2331720" cy="411480"/>
-          </a:xfrm>
-          <a:prstGeom prst="rect">
-            <a:avLst/>
-          </a:prstGeom>
-          <a:noFill/>
-        </p:spPr>
-        <p:txBody>
-          <a:bodyPr wrap="square" lIns="0" tIns="0" rIns="0" bIns="0" anchor="t">
-            <a:spAutoFit/>
-          </a:bodyPr>
-          <a:lstStyle/>
-          <a:p>
-            <a:pPr algn="l">
-              <a:lnSpc>
-                <a:spcPct val="115000"/>
-              </a:lnSpc>
-            </a:pPr>
-            <a:r>
-              <a:rPr sz="1100" b="0">
-                <a:solidFill>
-                  <a:srgbClr val="97A6BA"/>
-                </a:solidFill>
-                <a:latin typeface="Arial"/>
-              </a:rPr>
-              <a:t>Container image</a:t>
-            </a:r>
-          </a:p>
-        </p:txBody>
-      </p:sp>
-      <p:sp>
-        <p:nvSpPr>
           <p:cNvPr id="34" name="Rounded Rectangle 33"/>
           <p:cNvSpPr/>
           <p:nvPr/>
@@ -18675,84 +18597,6 @@
       </p:pic>
       <p:sp>
         <p:nvSpPr>
-          <p:cNvPr id="36" name="TextBox 35"/>
-          <p:cNvSpPr txBox="1"/>
-          <p:nvPr/>
-        </p:nvSpPr>
-        <p:spPr>
-          <a:xfrm>
-            <a:off x="5532120" y="4910328"/>
-            <a:ext cx="2331720" cy="457200"/>
-          </a:xfrm>
-          <a:prstGeom prst="rect">
-            <a:avLst/>
-          </a:prstGeom>
-          <a:noFill/>
-        </p:spPr>
-        <p:txBody>
-          <a:bodyPr wrap="square" lIns="0" tIns="0" rIns="0" bIns="0" anchor="t">
-            <a:spAutoFit/>
-          </a:bodyPr>
-          <a:lstStyle/>
-          <a:p>
-            <a:pPr algn="l">
-              <a:lnSpc>
-                <a:spcPct val="115000"/>
-              </a:lnSpc>
-            </a:pPr>
-            <a:r>
-              <a:rPr sz="1600" b="1">
-                <a:solidFill>
-                  <a:srgbClr val="FFFFFF"/>
-                </a:solidFill>
-                <a:latin typeface="Trebuchet MS"/>
-              </a:rPr>
-              <a:t>IAM</a:t>
-            </a:r>
-          </a:p>
-        </p:txBody>
-      </p:sp>
-      <p:sp>
-        <p:nvSpPr>
-          <p:cNvPr id="37" name="TextBox 36"/>
-          <p:cNvSpPr txBox="1"/>
-          <p:nvPr/>
-        </p:nvSpPr>
-        <p:spPr>
-          <a:xfrm>
-            <a:off x="5532120" y="5367528"/>
-            <a:ext cx="2331720" cy="411480"/>
-          </a:xfrm>
-          <a:prstGeom prst="rect">
-            <a:avLst/>
-          </a:prstGeom>
-          <a:noFill/>
-        </p:spPr>
-        <p:txBody>
-          <a:bodyPr wrap="square" lIns="0" tIns="0" rIns="0" bIns="0" anchor="t">
-            <a:spAutoFit/>
-          </a:bodyPr>
-          <a:lstStyle/>
-          <a:p>
-            <a:pPr algn="l">
-              <a:lnSpc>
-                <a:spcPct val="115000"/>
-              </a:lnSpc>
-            </a:pPr>
-            <a:r>
-              <a:rPr sz="1100" b="0">
-                <a:solidFill>
-                  <a:srgbClr val="97A6BA"/>
-                </a:solidFill>
-                <a:latin typeface="Arial"/>
-              </a:rPr>
-              <a:t>Least-priv roles</a:t>
-            </a:r>
-          </a:p>
-        </p:txBody>
-      </p:sp>
-      <p:sp>
-        <p:nvSpPr>
           <p:cNvPr id="38" name="Rounded Rectangle 37"/>
           <p:cNvSpPr/>
           <p:nvPr/>
@@ -18821,84 +18665,6 @@
           </a:prstGeom>
         </p:spPr>
       </p:pic>
-      <p:sp>
-        <p:nvSpPr>
-          <p:cNvPr id="40" name="TextBox 39"/>
-          <p:cNvSpPr txBox="1"/>
-          <p:nvPr/>
-        </p:nvSpPr>
-        <p:spPr>
-          <a:xfrm>
-            <a:off x="9235440" y="4910328"/>
-            <a:ext cx="2331720" cy="457200"/>
-          </a:xfrm>
-          <a:prstGeom prst="rect">
-            <a:avLst/>
-          </a:prstGeom>
-          <a:noFill/>
-        </p:spPr>
-        <p:txBody>
-          <a:bodyPr wrap="square" lIns="0" tIns="0" rIns="0" bIns="0" anchor="t">
-            <a:spAutoFit/>
-          </a:bodyPr>
-          <a:lstStyle/>
-          <a:p>
-            <a:pPr algn="l">
-              <a:lnSpc>
-                <a:spcPct val="115000"/>
-              </a:lnSpc>
-            </a:pPr>
-            <a:r>
-              <a:rPr sz="1600" b="1">
-                <a:solidFill>
-                  <a:srgbClr val="FFFFFF"/>
-                </a:solidFill>
-                <a:latin typeface="Trebuchet MS"/>
-              </a:rPr>
-              <a:t>CloudWatch</a:t>
-            </a:r>
-          </a:p>
-        </p:txBody>
-      </p:sp>
-      <p:sp>
-        <p:nvSpPr>
-          <p:cNvPr id="41" name="TextBox 40"/>
-          <p:cNvSpPr txBox="1"/>
-          <p:nvPr/>
-        </p:nvSpPr>
-        <p:spPr>
-          <a:xfrm>
-            <a:off x="9235440" y="5367528"/>
-            <a:ext cx="2331720" cy="411480"/>
-          </a:xfrm>
-          <a:prstGeom prst="rect">
-            <a:avLst/>
-          </a:prstGeom>
-          <a:noFill/>
-        </p:spPr>
-        <p:txBody>
-          <a:bodyPr wrap="square" lIns="0" tIns="0" rIns="0" bIns="0" anchor="t">
-            <a:spAutoFit/>
-          </a:bodyPr>
-          <a:lstStyle/>
-          <a:p>
-            <a:pPr algn="l">
-              <a:lnSpc>
-                <a:spcPct val="115000"/>
-              </a:lnSpc>
-            </a:pPr>
-            <a:r>
-              <a:rPr sz="1100" b="0">
-                <a:solidFill>
-                  <a:srgbClr val="97A6BA"/>
-                </a:solidFill>
-                <a:latin typeface="Arial"/>
-              </a:rPr>
-              <a:t>Logs+dash+alarm</a:t>
-            </a:r>
-          </a:p>
-        </p:txBody>
-      </p:sp>
       <p:pic>
         <p:nvPicPr>
           <p:cNvPr id="42" name="Picture 41" descr="fcj-logo-lockup.png"/>

</xml_diff>

<commit_message>
slides: trim extensions slide to Twilio + multi-language only
Drop the Amazon Connect pivot and 'v2.0 DROP' rows; keep v2.0 Twilio and
the future/multi-language row, moved up to close the gap.

Co-Authored-By: Claude Opus 4.8 <noreply@anthropic.com>
</commit_message>
<xml_diff>
--- a/docs/slides/Hera-Voice-Agent-Sharing.pptx
+++ b/docs/slides/Hera-Voice-Agent-Sharing.pptx
@@ -10826,7 +10826,7 @@
       </p:sp>
       <p:sp>
         <p:nvSpPr>
-          <p:cNvPr id="11" name="Rounded Rectangle 10"/>
+          <p:cNvPr id="21" name="Rounded Rectangle 20"/>
           <p:cNvSpPr/>
           <p:nvPr/>
         </p:nvSpPr>
@@ -10841,7 +10841,7 @@
             </a:avLst>
           </a:prstGeom>
           <a:solidFill>
-            <a:srgbClr val="FF8A3D"/>
+            <a:srgbClr val="8C4FFF"/>
           </a:solidFill>
           <a:ln>
             <a:noFill/>
@@ -10872,7 +10872,7 @@
       </p:sp>
       <p:sp>
         <p:nvSpPr>
-          <p:cNvPr id="12" name="TextBox 11"/>
+          <p:cNvPr id="22" name="TextBox 21"/>
           <p:cNvSpPr txBox="1"/>
           <p:nvPr/>
         </p:nvSpPr>
@@ -10904,14 +10904,14 @@
                 </a:solidFill>
                 <a:latin typeface="Trebuchet MS"/>
               </a:rPr>
-              <a:t>v2.0 → Connect</a:t>
-            </a:r>
-          </a:p>
-        </p:txBody>
-      </p:sp>
-      <p:sp>
-        <p:nvSpPr>
-          <p:cNvPr id="13" name="Rounded Rectangle 12"/>
+              <a:t>Tương lai</a:t>
+            </a:r>
+          </a:p>
+        </p:txBody>
+      </p:sp>
+      <p:sp>
+        <p:nvSpPr>
+          <p:cNvPr id="23" name="Rounded Rectangle 22"/>
           <p:cNvSpPr/>
           <p:nvPr/>
         </p:nvSpPr>
@@ -10957,7 +10957,7 @@
       </p:sp>
       <p:sp>
         <p:nvSpPr>
-          <p:cNvPr id="14" name="TextBox 13"/>
+          <p:cNvPr id="24" name="TextBox 23"/>
           <p:cNvSpPr txBox="1"/>
           <p:nvPr/>
         </p:nvSpPr>
@@ -10989,424 +10989,6 @@
                 </a:solidFill>
                 <a:latin typeface="Trebuchet MS"/>
               </a:rPr>
-              <a:t>Pivot sang Amazon Connect + Lex V2 + Polly Neural</a:t>
-            </a:r>
-          </a:p>
-        </p:txBody>
-      </p:sp>
-      <p:sp>
-        <p:nvSpPr>
-          <p:cNvPr id="15" name="TextBox 14"/>
-          <p:cNvSpPr txBox="1"/>
-          <p:nvPr/>
-        </p:nvSpPr>
-        <p:spPr>
-          <a:xfrm>
-            <a:off x="2697480" y="3438143"/>
-            <a:ext cx="8961120" cy="457200"/>
-          </a:xfrm>
-          <a:prstGeom prst="rect">
-            <a:avLst/>
-          </a:prstGeom>
-          <a:noFill/>
-        </p:spPr>
-        <p:txBody>
-          <a:bodyPr wrap="square" lIns="0" tIns="0" rIns="0" bIns="0" anchor="t">
-            <a:spAutoFit/>
-          </a:bodyPr>
-          <a:lstStyle/>
-          <a:p>
-            <a:pPr algn="l">
-              <a:lnSpc>
-                <a:spcPct val="135000"/>
-              </a:lnSpc>
-            </a:pPr>
-            <a:r>
-              <a:rPr sz="1100" b="0">
-                <a:solidFill>
-                  <a:srgbClr val="97A6BA"/>
-                </a:solidFill>
-                <a:latin typeface="Arial"/>
-              </a:rPr>
-              <a:t>Phát hiện: IVR-style, gap 3-5s vs Sonic &lt;2s</a:t>
-            </a:r>
-          </a:p>
-        </p:txBody>
-      </p:sp>
-      <p:sp>
-        <p:nvSpPr>
-          <p:cNvPr id="16" name="Rounded Rectangle 15"/>
-          <p:cNvSpPr/>
-          <p:nvPr/>
-        </p:nvSpPr>
-        <p:spPr>
-          <a:xfrm>
-            <a:off x="640080" y="4032502"/>
-            <a:ext cx="1828800" cy="1033271"/>
-          </a:xfrm>
-          <a:prstGeom prst="roundRect">
-            <a:avLst>
-              <a:gd name="adj" fmla="val 5000"/>
-            </a:avLst>
-          </a:prstGeom>
-          <a:solidFill>
-            <a:srgbClr val="D43AC8"/>
-          </a:solidFill>
-          <a:ln>
-            <a:noFill/>
-          </a:ln>
-        </p:spPr>
-        <p:style>
-          <a:lnRef idx="1">
-            <a:schemeClr val="accent1"/>
-          </a:lnRef>
-          <a:fillRef idx="3">
-            <a:schemeClr val="accent1"/>
-          </a:fillRef>
-          <a:effectRef idx="2">
-            <a:schemeClr val="accent1"/>
-          </a:effectRef>
-          <a:fontRef idx="minor">
-            <a:schemeClr val="lt1"/>
-          </a:fontRef>
-        </p:style>
-        <p:txBody>
-          <a:bodyPr rtlCol="0" anchor="ctr"/>
-          <a:lstStyle/>
-          <a:p>
-            <a:pPr algn="ctr"/>
-            <a:endParaRPr/>
-          </a:p>
-        </p:txBody>
-      </p:sp>
-      <p:sp>
-        <p:nvSpPr>
-          <p:cNvPr id="17" name="TextBox 16"/>
-          <p:cNvSpPr txBox="1"/>
-          <p:nvPr/>
-        </p:nvSpPr>
-        <p:spPr>
-          <a:xfrm>
-            <a:off x="640080" y="4032502"/>
-            <a:ext cx="1828800" cy="1033271"/>
-          </a:xfrm>
-          <a:prstGeom prst="rect">
-            <a:avLst/>
-          </a:prstGeom>
-          <a:noFill/>
-        </p:spPr>
-        <p:txBody>
-          <a:bodyPr wrap="square" lIns="0" tIns="0" rIns="0" bIns="0" anchor="ctr">
-            <a:spAutoFit/>
-          </a:bodyPr>
-          <a:lstStyle/>
-          <a:p>
-            <a:pPr algn="ctr">
-              <a:lnSpc>
-                <a:spcPct val="115000"/>
-              </a:lnSpc>
-            </a:pPr>
-            <a:r>
-              <a:rPr sz="1400" b="1">
-                <a:solidFill>
-                  <a:srgbClr val="FFFFFF"/>
-                </a:solidFill>
-                <a:latin typeface="Trebuchet MS"/>
-              </a:rPr>
-              <a:t>v2.0 DROP</a:t>
-            </a:r>
-          </a:p>
-        </p:txBody>
-      </p:sp>
-      <p:sp>
-        <p:nvSpPr>
-          <p:cNvPr id="18" name="Rounded Rectangle 17"/>
-          <p:cNvSpPr/>
-          <p:nvPr/>
-        </p:nvSpPr>
-        <p:spPr>
-          <a:xfrm>
-            <a:off x="2514600" y="4032502"/>
-            <a:ext cx="9189720" cy="1033271"/>
-          </a:xfrm>
-          <a:prstGeom prst="roundRect">
-            <a:avLst>
-              <a:gd name="adj" fmla="val 5000"/>
-            </a:avLst>
-          </a:prstGeom>
-          <a:solidFill>
-            <a:srgbClr val="162033"/>
-          </a:solidFill>
-          <a:ln>
-            <a:noFill/>
-          </a:ln>
-        </p:spPr>
-        <p:style>
-          <a:lnRef idx="1">
-            <a:schemeClr val="accent1"/>
-          </a:lnRef>
-          <a:fillRef idx="3">
-            <a:schemeClr val="accent1"/>
-          </a:fillRef>
-          <a:effectRef idx="2">
-            <a:schemeClr val="accent1"/>
-          </a:effectRef>
-          <a:fontRef idx="minor">
-            <a:schemeClr val="lt1"/>
-          </a:fontRef>
-        </p:style>
-        <p:txBody>
-          <a:bodyPr rtlCol="0" anchor="ctr"/>
-          <a:lstStyle/>
-          <a:p>
-            <a:pPr algn="ctr"/>
-            <a:endParaRPr/>
-          </a:p>
-        </p:txBody>
-      </p:sp>
-      <p:sp>
-        <p:nvSpPr>
-          <p:cNvPr id="19" name="TextBox 18"/>
-          <p:cNvSpPr txBox="1"/>
-          <p:nvPr/>
-        </p:nvSpPr>
-        <p:spPr>
-          <a:xfrm>
-            <a:off x="2697480" y="4142230"/>
-            <a:ext cx="8961120" cy="457200"/>
-          </a:xfrm>
-          <a:prstGeom prst="rect">
-            <a:avLst/>
-          </a:prstGeom>
-          <a:noFill/>
-        </p:spPr>
-        <p:txBody>
-          <a:bodyPr wrap="square" lIns="0" tIns="0" rIns="0" bIns="0" anchor="t">
-            <a:spAutoFit/>
-          </a:bodyPr>
-          <a:lstStyle/>
-          <a:p>
-            <a:pPr algn="l">
-              <a:lnSpc>
-                <a:spcPct val="115000"/>
-              </a:lnSpc>
-            </a:pPr>
-            <a:r>
-              <a:rPr sz="1400" b="1">
-                <a:solidFill>
-                  <a:srgbClr val="FFFFFF"/>
-                </a:solidFill>
-                <a:latin typeface="Trebuchet MS"/>
-              </a:rPr>
-              <a:t>Giữ nguyên v1 Nova Sonic web — newest tech</a:t>
-            </a:r>
-          </a:p>
-        </p:txBody>
-      </p:sp>
-      <p:sp>
-        <p:nvSpPr>
-          <p:cNvPr id="20" name="TextBox 19"/>
-          <p:cNvSpPr txBox="1"/>
-          <p:nvPr/>
-        </p:nvSpPr>
-        <p:spPr>
-          <a:xfrm>
-            <a:off x="2697480" y="4562854"/>
-            <a:ext cx="8961120" cy="457200"/>
-          </a:xfrm>
-          <a:prstGeom prst="rect">
-            <a:avLst/>
-          </a:prstGeom>
-          <a:noFill/>
-        </p:spPr>
-        <p:txBody>
-          <a:bodyPr wrap="square" lIns="0" tIns="0" rIns="0" bIns="0" anchor="t">
-            <a:spAutoFit/>
-          </a:bodyPr>
-          <a:lstStyle/>
-          <a:p>
-            <a:pPr algn="l">
-              <a:lnSpc>
-                <a:spcPct val="135000"/>
-              </a:lnSpc>
-            </a:pPr>
-            <a:r>
-              <a:rPr sz="1100" b="0">
-                <a:solidFill>
-                  <a:srgbClr val="97A6BA"/>
-                </a:solidFill>
-                <a:latin typeface="Arial"/>
-              </a:rPr>
-              <a:t>Speech-to-speech là hướng đi đúng của ngành</a:t>
-            </a:r>
-          </a:p>
-        </p:txBody>
-      </p:sp>
-      <p:sp>
-        <p:nvSpPr>
-          <p:cNvPr id="21" name="Rounded Rectangle 20"/>
-          <p:cNvSpPr/>
-          <p:nvPr/>
-        </p:nvSpPr>
-        <p:spPr>
-          <a:xfrm>
-            <a:off x="640080" y="5157213"/>
-            <a:ext cx="1828800" cy="1033271"/>
-          </a:xfrm>
-          <a:prstGeom prst="roundRect">
-            <a:avLst>
-              <a:gd name="adj" fmla="val 5000"/>
-            </a:avLst>
-          </a:prstGeom>
-          <a:solidFill>
-            <a:srgbClr val="8C4FFF"/>
-          </a:solidFill>
-          <a:ln>
-            <a:noFill/>
-          </a:ln>
-        </p:spPr>
-        <p:style>
-          <a:lnRef idx="1">
-            <a:schemeClr val="accent1"/>
-          </a:lnRef>
-          <a:fillRef idx="3">
-            <a:schemeClr val="accent1"/>
-          </a:fillRef>
-          <a:effectRef idx="2">
-            <a:schemeClr val="accent1"/>
-          </a:effectRef>
-          <a:fontRef idx="minor">
-            <a:schemeClr val="lt1"/>
-          </a:fontRef>
-        </p:style>
-        <p:txBody>
-          <a:bodyPr rtlCol="0" anchor="ctr"/>
-          <a:lstStyle/>
-          <a:p>
-            <a:pPr algn="ctr"/>
-            <a:endParaRPr/>
-          </a:p>
-        </p:txBody>
-      </p:sp>
-      <p:sp>
-        <p:nvSpPr>
-          <p:cNvPr id="22" name="TextBox 21"/>
-          <p:cNvSpPr txBox="1"/>
-          <p:nvPr/>
-        </p:nvSpPr>
-        <p:spPr>
-          <a:xfrm>
-            <a:off x="640080" y="5157213"/>
-            <a:ext cx="1828800" cy="1033271"/>
-          </a:xfrm>
-          <a:prstGeom prst="rect">
-            <a:avLst/>
-          </a:prstGeom>
-          <a:noFill/>
-        </p:spPr>
-        <p:txBody>
-          <a:bodyPr wrap="square" lIns="0" tIns="0" rIns="0" bIns="0" anchor="ctr">
-            <a:spAutoFit/>
-          </a:bodyPr>
-          <a:lstStyle/>
-          <a:p>
-            <a:pPr algn="ctr">
-              <a:lnSpc>
-                <a:spcPct val="115000"/>
-              </a:lnSpc>
-            </a:pPr>
-            <a:r>
-              <a:rPr sz="1400" b="1">
-                <a:solidFill>
-                  <a:srgbClr val="FFFFFF"/>
-                </a:solidFill>
-                <a:latin typeface="Trebuchet MS"/>
-              </a:rPr>
-              <a:t>Tương lai</a:t>
-            </a:r>
-          </a:p>
-        </p:txBody>
-      </p:sp>
-      <p:sp>
-        <p:nvSpPr>
-          <p:cNvPr id="23" name="Rounded Rectangle 22"/>
-          <p:cNvSpPr/>
-          <p:nvPr/>
-        </p:nvSpPr>
-        <p:spPr>
-          <a:xfrm>
-            <a:off x="2514600" y="5157213"/>
-            <a:ext cx="9189720" cy="1033271"/>
-          </a:xfrm>
-          <a:prstGeom prst="roundRect">
-            <a:avLst>
-              <a:gd name="adj" fmla="val 5000"/>
-            </a:avLst>
-          </a:prstGeom>
-          <a:solidFill>
-            <a:srgbClr val="162033"/>
-          </a:solidFill>
-          <a:ln>
-            <a:noFill/>
-          </a:ln>
-        </p:spPr>
-        <p:style>
-          <a:lnRef idx="1">
-            <a:schemeClr val="accent1"/>
-          </a:lnRef>
-          <a:fillRef idx="3">
-            <a:schemeClr val="accent1"/>
-          </a:fillRef>
-          <a:effectRef idx="2">
-            <a:schemeClr val="accent1"/>
-          </a:effectRef>
-          <a:fontRef idx="minor">
-            <a:schemeClr val="lt1"/>
-          </a:fontRef>
-        </p:style>
-        <p:txBody>
-          <a:bodyPr rtlCol="0" anchor="ctr"/>
-          <a:lstStyle/>
-          <a:p>
-            <a:pPr algn="ctr"/>
-            <a:endParaRPr/>
-          </a:p>
-        </p:txBody>
-      </p:sp>
-      <p:sp>
-        <p:nvSpPr>
-          <p:cNvPr id="24" name="TextBox 23"/>
-          <p:cNvSpPr txBox="1"/>
-          <p:nvPr/>
-        </p:nvSpPr>
-        <p:spPr>
-          <a:xfrm>
-            <a:off x="2697480" y="5266941"/>
-            <a:ext cx="8961120" cy="457200"/>
-          </a:xfrm>
-          <a:prstGeom prst="rect">
-            <a:avLst/>
-          </a:prstGeom>
-          <a:noFill/>
-        </p:spPr>
-        <p:txBody>
-          <a:bodyPr wrap="square" lIns="0" tIns="0" rIns="0" bIns="0" anchor="t">
-            <a:spAutoFit/>
-          </a:bodyPr>
-          <a:lstStyle/>
-          <a:p>
-            <a:pPr algn="l">
-              <a:lnSpc>
-                <a:spcPct val="115000"/>
-              </a:lnSpc>
-            </a:pPr>
-            <a:r>
-              <a:rPr sz="1400" b="1">
-                <a:solidFill>
-                  <a:srgbClr val="FFFFFF"/>
-                </a:solidFill>
-                <a:latin typeface="Trebuchet MS"/>
-              </a:rPr>
               <a:t>Multi-language, multi-agent routing</a:t>
             </a:r>
           </a:p>
@@ -11420,7 +11002,7 @@
         </p:nvSpPr>
         <p:spPr>
           <a:xfrm>
-            <a:off x="2697480" y="5687565"/>
+            <a:off x="2697480" y="3438143"/>
             <a:ext cx="8961120" cy="457200"/>
           </a:xfrm>
           <a:prstGeom prst="rect">

</xml_diff>

<commit_message>
slides: add AWS template for Hera Voice Agent sharing
</commit_message>
<xml_diff>
--- a/docs/slides/Hera-Voice-Agent-Sharing.pptx
+++ b/docs/slides/Hera-Voice-Agent-Sharing.pptx
@@ -4,6 +4,9 @@
   <p:sldMasterIdLst>
     <p:sldMasterId id="2147483648" r:id="rId1"/>
   </p:sldMasterIdLst>
+  <p:notesMasterIdLst>
+    <p:notesMasterId r:id="rId21"/>
+  </p:notesMasterIdLst>
   <p:sldIdLst>
     <p:sldId id="256" r:id="rId2"/>
     <p:sldId id="257" r:id="rId3"/>
@@ -17,13 +20,13 @@
     <p:sldId id="267" r:id="rId11"/>
     <p:sldId id="268" r:id="rId12"/>
     <p:sldId id="269" r:id="rId13"/>
-    <p:sldId id="263" r:id="rId15"/>
-    <p:sldId id="271" r:id="rId16"/>
-    <p:sldId id="272" r:id="rId17"/>
-    <p:sldId id="273" r:id="rId18"/>
-    <p:sldId id="275" r:id="rId19"/>
-    <p:sldId id="274" r:id="rId20"/>
-    <p:sldId id="276" r:id="rId21"/>
+    <p:sldId id="263" r:id="rId14"/>
+    <p:sldId id="271" r:id="rId15"/>
+    <p:sldId id="272" r:id="rId16"/>
+    <p:sldId id="273" r:id="rId17"/>
+    <p:sldId id="275" r:id="rId18"/>
+    <p:sldId id="274" r:id="rId19"/>
+    <p:sldId id="276" r:id="rId20"/>
   </p:sldIdLst>
   <p:sldSz cx="12192000" cy="6858000"/>
   <p:notesSz cx="6858000" cy="9144000"/>
@@ -139,6 +142,439 @@
     </p:ext>
   </p:extLst>
 </p:presentation>
+</file>
+
+<file path=ppt/notesMasters/notesMaster1.xml><?xml version="1.0" encoding="utf-8"?>
+<p:notesMaster xmlns:a="http://schemas.openxmlformats.org/drawingml/2006/main" xmlns:r="http://schemas.openxmlformats.org/officeDocument/2006/relationships" xmlns:p="http://schemas.openxmlformats.org/presentationml/2006/main">
+  <p:cSld>
+    <p:bg>
+      <p:bgRef idx="1001">
+        <a:schemeClr val="bg1"/>
+      </p:bgRef>
+    </p:bg>
+    <p:spTree>
+      <p:nvGrpSpPr>
+        <p:cNvPr id="1" name=""/>
+        <p:cNvGrpSpPr/>
+        <p:nvPr/>
+      </p:nvGrpSpPr>
+      <p:grpSpPr>
+        <a:xfrm>
+          <a:off x="0" y="0"/>
+          <a:ext cx="0" cy="0"/>
+          <a:chOff x="0" y="0"/>
+          <a:chExt cx="0" cy="0"/>
+        </a:xfrm>
+      </p:grpSpPr>
+      <p:sp>
+        <p:nvSpPr>
+          <p:cNvPr id="2" name="Header Placeholder 1"/>
+          <p:cNvSpPr>
+            <a:spLocks noGrp="1"/>
+          </p:cNvSpPr>
+          <p:nvPr>
+            <p:ph type="hdr" sz="quarter"/>
+          </p:nvPr>
+        </p:nvSpPr>
+        <p:spPr>
+          <a:xfrm>
+            <a:off x="0" y="0"/>
+            <a:ext cx="2971800" cy="458788"/>
+          </a:xfrm>
+          <a:prstGeom prst="rect">
+            <a:avLst/>
+          </a:prstGeom>
+        </p:spPr>
+        <p:txBody>
+          <a:bodyPr vert="horz" lIns="91440" tIns="45720" rIns="91440" bIns="45720" rtlCol="0"/>
+          <a:lstStyle>
+            <a:lvl1pPr algn="l">
+              <a:defRPr sz="1200"/>
+            </a:lvl1pPr>
+          </a:lstStyle>
+          <a:p>
+            <a:endParaRPr lang="en-US"/>
+          </a:p>
+        </p:txBody>
+      </p:sp>
+      <p:sp>
+        <p:nvSpPr>
+          <p:cNvPr id="3" name="Date Placeholder 2"/>
+          <p:cNvSpPr>
+            <a:spLocks noGrp="1"/>
+          </p:cNvSpPr>
+          <p:nvPr>
+            <p:ph type="dt" idx="1"/>
+          </p:nvPr>
+        </p:nvSpPr>
+        <p:spPr>
+          <a:xfrm>
+            <a:off x="3884613" y="0"/>
+            <a:ext cx="2971800" cy="458788"/>
+          </a:xfrm>
+          <a:prstGeom prst="rect">
+            <a:avLst/>
+          </a:prstGeom>
+        </p:spPr>
+        <p:txBody>
+          <a:bodyPr vert="horz" lIns="91440" tIns="45720" rIns="91440" bIns="45720" rtlCol="0"/>
+          <a:lstStyle>
+            <a:lvl1pPr algn="r">
+              <a:defRPr sz="1200"/>
+            </a:lvl1pPr>
+          </a:lstStyle>
+          <a:p>
+            <a:fld id="{F58CA969-5D7D-4869-9174-3302CF1C5DF0}" type="datetimeFigureOut">
+              <a:rPr lang="en-US" smtClean="0"/>
+              <a:t>5/30/2026</a:t>
+            </a:fld>
+            <a:endParaRPr lang="en-US"/>
+          </a:p>
+        </p:txBody>
+      </p:sp>
+      <p:sp>
+        <p:nvSpPr>
+          <p:cNvPr id="4" name="Slide Image Placeholder 3"/>
+          <p:cNvSpPr>
+            <a:spLocks noGrp="1" noRot="1" noChangeAspect="1"/>
+          </p:cNvSpPr>
+          <p:nvPr>
+            <p:ph type="sldImg" idx="2"/>
+          </p:nvPr>
+        </p:nvSpPr>
+        <p:spPr>
+          <a:xfrm>
+            <a:off x="685800" y="1143000"/>
+            <a:ext cx="5486400" cy="3086100"/>
+          </a:xfrm>
+          <a:prstGeom prst="rect">
+            <a:avLst/>
+          </a:prstGeom>
+          <a:noFill/>
+          <a:ln w="12700">
+            <a:solidFill>
+              <a:prstClr val="black"/>
+            </a:solidFill>
+          </a:ln>
+        </p:spPr>
+        <p:txBody>
+          <a:bodyPr vert="horz" lIns="91440" tIns="45720" rIns="91440" bIns="45720" rtlCol="0" anchor="ctr"/>
+          <a:lstStyle/>
+          <a:p>
+            <a:endParaRPr lang="en-US"/>
+          </a:p>
+        </p:txBody>
+      </p:sp>
+      <p:sp>
+        <p:nvSpPr>
+          <p:cNvPr id="5" name="Notes Placeholder 4"/>
+          <p:cNvSpPr>
+            <a:spLocks noGrp="1"/>
+          </p:cNvSpPr>
+          <p:nvPr>
+            <p:ph type="body" sz="quarter" idx="3"/>
+          </p:nvPr>
+        </p:nvSpPr>
+        <p:spPr>
+          <a:xfrm>
+            <a:off x="685800" y="4400550"/>
+            <a:ext cx="5486400" cy="3600450"/>
+          </a:xfrm>
+          <a:prstGeom prst="rect">
+            <a:avLst/>
+          </a:prstGeom>
+        </p:spPr>
+        <p:txBody>
+          <a:bodyPr vert="horz" lIns="91440" tIns="45720" rIns="91440" bIns="45720" rtlCol="0"/>
+          <a:lstStyle/>
+          <a:p>
+            <a:pPr lvl="0"/>
+            <a:r>
+              <a:rPr lang="en-US"/>
+              <a:t>Click to edit Master text styles</a:t>
+            </a:r>
+          </a:p>
+          <a:p>
+            <a:pPr lvl="1"/>
+            <a:r>
+              <a:rPr lang="en-US"/>
+              <a:t>Second level</a:t>
+            </a:r>
+          </a:p>
+          <a:p>
+            <a:pPr lvl="2"/>
+            <a:r>
+              <a:rPr lang="en-US"/>
+              <a:t>Third level</a:t>
+            </a:r>
+          </a:p>
+          <a:p>
+            <a:pPr lvl="3"/>
+            <a:r>
+              <a:rPr lang="en-US"/>
+              <a:t>Fourth level</a:t>
+            </a:r>
+          </a:p>
+          <a:p>
+            <a:pPr lvl="4"/>
+            <a:r>
+              <a:rPr lang="en-US"/>
+              <a:t>Fifth level</a:t>
+            </a:r>
+          </a:p>
+        </p:txBody>
+      </p:sp>
+      <p:sp>
+        <p:nvSpPr>
+          <p:cNvPr id="6" name="Footer Placeholder 5"/>
+          <p:cNvSpPr>
+            <a:spLocks noGrp="1"/>
+          </p:cNvSpPr>
+          <p:nvPr>
+            <p:ph type="ftr" sz="quarter" idx="4"/>
+          </p:nvPr>
+        </p:nvSpPr>
+        <p:spPr>
+          <a:xfrm>
+            <a:off x="0" y="8685213"/>
+            <a:ext cx="2971800" cy="458787"/>
+          </a:xfrm>
+          <a:prstGeom prst="rect">
+            <a:avLst/>
+          </a:prstGeom>
+        </p:spPr>
+        <p:txBody>
+          <a:bodyPr vert="horz" lIns="91440" tIns="45720" rIns="91440" bIns="45720" rtlCol="0" anchor="b"/>
+          <a:lstStyle>
+            <a:lvl1pPr algn="l">
+              <a:defRPr sz="1200"/>
+            </a:lvl1pPr>
+          </a:lstStyle>
+          <a:p>
+            <a:endParaRPr lang="en-US"/>
+          </a:p>
+        </p:txBody>
+      </p:sp>
+      <p:sp>
+        <p:nvSpPr>
+          <p:cNvPr id="7" name="Slide Number Placeholder 6"/>
+          <p:cNvSpPr>
+            <a:spLocks noGrp="1"/>
+          </p:cNvSpPr>
+          <p:nvPr>
+            <p:ph type="sldNum" sz="quarter" idx="5"/>
+          </p:nvPr>
+        </p:nvSpPr>
+        <p:spPr>
+          <a:xfrm>
+            <a:off x="3884613" y="8685213"/>
+            <a:ext cx="2971800" cy="458787"/>
+          </a:xfrm>
+          <a:prstGeom prst="rect">
+            <a:avLst/>
+          </a:prstGeom>
+        </p:spPr>
+        <p:txBody>
+          <a:bodyPr vert="horz" lIns="91440" tIns="45720" rIns="91440" bIns="45720" rtlCol="0" anchor="b"/>
+          <a:lstStyle>
+            <a:lvl1pPr algn="r">
+              <a:defRPr sz="1200"/>
+            </a:lvl1pPr>
+          </a:lstStyle>
+          <a:p>
+            <a:fld id="{BF885D25-560A-4369-898B-3B8DCB089120}" type="slidenum">
+              <a:rPr lang="en-US" smtClean="0"/>
+              <a:t>‹#›</a:t>
+            </a:fld>
+            <a:endParaRPr lang="en-US"/>
+          </a:p>
+        </p:txBody>
+      </p:sp>
+    </p:spTree>
+    <p:extLst>
+      <p:ext uri="{BB962C8B-B14F-4D97-AF65-F5344CB8AC3E}">
+        <p14:creationId xmlns:p14="http://schemas.microsoft.com/office/powerpoint/2010/main" val="2233981492"/>
+      </p:ext>
+    </p:extLst>
+  </p:cSld>
+  <p:clrMap bg1="lt1" tx1="dk1" bg2="lt2" tx2="dk2" accent1="accent1" accent2="accent2" accent3="accent3" accent4="accent4" accent5="accent5" accent6="accent6" hlink="hlink" folHlink="folHlink"/>
+  <p:notesStyle>
+    <a:lvl1pPr marL="0" algn="l" defTabSz="914400" rtl="0" eaLnBrk="1" latinLnBrk="0" hangingPunct="1">
+      <a:defRPr sz="1200" kern="1200">
+        <a:solidFill>
+          <a:schemeClr val="tx1"/>
+        </a:solidFill>
+        <a:latin typeface="+mn-lt"/>
+        <a:ea typeface="+mn-ea"/>
+        <a:cs typeface="+mn-cs"/>
+      </a:defRPr>
+    </a:lvl1pPr>
+    <a:lvl2pPr marL="457200" algn="l" defTabSz="914400" rtl="0" eaLnBrk="1" latinLnBrk="0" hangingPunct="1">
+      <a:defRPr sz="1200" kern="1200">
+        <a:solidFill>
+          <a:schemeClr val="tx1"/>
+        </a:solidFill>
+        <a:latin typeface="+mn-lt"/>
+        <a:ea typeface="+mn-ea"/>
+        <a:cs typeface="+mn-cs"/>
+      </a:defRPr>
+    </a:lvl2pPr>
+    <a:lvl3pPr marL="914400" algn="l" defTabSz="914400" rtl="0" eaLnBrk="1" latinLnBrk="0" hangingPunct="1">
+      <a:defRPr sz="1200" kern="1200">
+        <a:solidFill>
+          <a:schemeClr val="tx1"/>
+        </a:solidFill>
+        <a:latin typeface="+mn-lt"/>
+        <a:ea typeface="+mn-ea"/>
+        <a:cs typeface="+mn-cs"/>
+      </a:defRPr>
+    </a:lvl3pPr>
+    <a:lvl4pPr marL="1371600" algn="l" defTabSz="914400" rtl="0" eaLnBrk="1" latinLnBrk="0" hangingPunct="1">
+      <a:defRPr sz="1200" kern="1200">
+        <a:solidFill>
+          <a:schemeClr val="tx1"/>
+        </a:solidFill>
+        <a:latin typeface="+mn-lt"/>
+        <a:ea typeface="+mn-ea"/>
+        <a:cs typeface="+mn-cs"/>
+      </a:defRPr>
+    </a:lvl4pPr>
+    <a:lvl5pPr marL="1828800" algn="l" defTabSz="914400" rtl="0" eaLnBrk="1" latinLnBrk="0" hangingPunct="1">
+      <a:defRPr sz="1200" kern="1200">
+        <a:solidFill>
+          <a:schemeClr val="tx1"/>
+        </a:solidFill>
+        <a:latin typeface="+mn-lt"/>
+        <a:ea typeface="+mn-ea"/>
+        <a:cs typeface="+mn-cs"/>
+      </a:defRPr>
+    </a:lvl5pPr>
+    <a:lvl6pPr marL="2286000" algn="l" defTabSz="914400" rtl="0" eaLnBrk="1" latinLnBrk="0" hangingPunct="1">
+      <a:defRPr sz="1200" kern="1200">
+        <a:solidFill>
+          <a:schemeClr val="tx1"/>
+        </a:solidFill>
+        <a:latin typeface="+mn-lt"/>
+        <a:ea typeface="+mn-ea"/>
+        <a:cs typeface="+mn-cs"/>
+      </a:defRPr>
+    </a:lvl6pPr>
+    <a:lvl7pPr marL="2743200" algn="l" defTabSz="914400" rtl="0" eaLnBrk="1" latinLnBrk="0" hangingPunct="1">
+      <a:defRPr sz="1200" kern="1200">
+        <a:solidFill>
+          <a:schemeClr val="tx1"/>
+        </a:solidFill>
+        <a:latin typeface="+mn-lt"/>
+        <a:ea typeface="+mn-ea"/>
+        <a:cs typeface="+mn-cs"/>
+      </a:defRPr>
+    </a:lvl7pPr>
+    <a:lvl8pPr marL="3200400" algn="l" defTabSz="914400" rtl="0" eaLnBrk="1" latinLnBrk="0" hangingPunct="1">
+      <a:defRPr sz="1200" kern="1200">
+        <a:solidFill>
+          <a:schemeClr val="tx1"/>
+        </a:solidFill>
+        <a:latin typeface="+mn-lt"/>
+        <a:ea typeface="+mn-ea"/>
+        <a:cs typeface="+mn-cs"/>
+      </a:defRPr>
+    </a:lvl8pPr>
+    <a:lvl9pPr marL="3657600" algn="l" defTabSz="914400" rtl="0" eaLnBrk="1" latinLnBrk="0" hangingPunct="1">
+      <a:defRPr sz="1200" kern="1200">
+        <a:solidFill>
+          <a:schemeClr val="tx1"/>
+        </a:solidFill>
+        <a:latin typeface="+mn-lt"/>
+        <a:ea typeface="+mn-ea"/>
+        <a:cs typeface="+mn-cs"/>
+      </a:defRPr>
+    </a:lvl9pPr>
+  </p:notesStyle>
+</p:notesMaster>
+</file>
+
+<file path=ppt/notesSlides/notesSlide1.xml><?xml version="1.0" encoding="utf-8"?>
+<p:notes xmlns:a="http://schemas.openxmlformats.org/drawingml/2006/main" xmlns:r="http://schemas.openxmlformats.org/officeDocument/2006/relationships" xmlns:p="http://schemas.openxmlformats.org/presentationml/2006/main">
+  <p:cSld>
+    <p:spTree>
+      <p:nvGrpSpPr>
+        <p:cNvPr id="1" name=""/>
+        <p:cNvGrpSpPr/>
+        <p:nvPr/>
+      </p:nvGrpSpPr>
+      <p:grpSpPr>
+        <a:xfrm>
+          <a:off x="0" y="0"/>
+          <a:ext cx="0" cy="0"/>
+          <a:chOff x="0" y="0"/>
+          <a:chExt cx="0" cy="0"/>
+        </a:xfrm>
+      </p:grpSpPr>
+      <p:sp>
+        <p:nvSpPr>
+          <p:cNvPr id="2" name="Slide Image Placeholder 1"/>
+          <p:cNvSpPr>
+            <a:spLocks noGrp="1" noRot="1" noChangeAspect="1"/>
+          </p:cNvSpPr>
+          <p:nvPr>
+            <p:ph type="sldImg"/>
+          </p:nvPr>
+        </p:nvSpPr>
+        <p:spPr/>
+      </p:sp>
+      <p:sp>
+        <p:nvSpPr>
+          <p:cNvPr id="3" name="Notes Placeholder 2"/>
+          <p:cNvSpPr>
+            <a:spLocks noGrp="1"/>
+          </p:cNvSpPr>
+          <p:nvPr>
+            <p:ph type="body" idx="1"/>
+          </p:nvPr>
+        </p:nvSpPr>
+        <p:spPr/>
+        <p:txBody>
+          <a:bodyPr/>
+          <a:lstStyle/>
+          <a:p>
+            <a:endParaRPr lang="en-US" dirty="0"/>
+          </a:p>
+        </p:txBody>
+      </p:sp>
+      <p:sp>
+        <p:nvSpPr>
+          <p:cNvPr id="4" name="Slide Number Placeholder 3"/>
+          <p:cNvSpPr>
+            <a:spLocks noGrp="1"/>
+          </p:cNvSpPr>
+          <p:nvPr>
+            <p:ph type="sldNum" sz="quarter" idx="5"/>
+          </p:nvPr>
+        </p:nvSpPr>
+        <p:spPr/>
+        <p:txBody>
+          <a:bodyPr/>
+          <a:lstStyle/>
+          <a:p>
+            <a:fld id="{BF885D25-560A-4369-898B-3B8DCB089120}" type="slidenum">
+              <a:rPr lang="en-US" smtClean="0"/>
+              <a:t>8</a:t>
+            </a:fld>
+            <a:endParaRPr lang="en-US"/>
+          </a:p>
+        </p:txBody>
+      </p:sp>
+    </p:spTree>
+    <p:extLst>
+      <p:ext uri="{BB962C8B-B14F-4D97-AF65-F5344CB8AC3E}">
+        <p14:creationId xmlns:p14="http://schemas.microsoft.com/office/powerpoint/2010/main" val="1962966071"/>
+      </p:ext>
+    </p:extLst>
+  </p:cSld>
+  <p:clrMapOvr>
+    <a:masterClrMapping/>
+  </p:clrMapOvr>
+</p:notes>
 </file>
 
 <file path=ppt/slideLayouts/slideLayout1.xml><?xml version="1.0" encoding="utf-8"?>
@@ -9684,13 +10120,31 @@
               </a:lnSpc>
             </a:pPr>
             <a:r>
-              <a:rPr sz="1100" b="0">
+              <a:rPr sz="1100" b="0" dirty="0">
                 <a:solidFill>
                   <a:srgbClr val="97A6BA"/>
                 </a:solidFill>
                 <a:latin typeface="Arial"/>
               </a:rPr>
-              <a:t>end-of-utt → audio</a:t>
+              <a:t>end-of-</a:t>
+            </a:r>
+            <a:r>
+              <a:rPr sz="1100" b="0" dirty="0" err="1">
+                <a:solidFill>
+                  <a:srgbClr val="97A6BA"/>
+                </a:solidFill>
+                <a:latin typeface="Arial"/>
+              </a:rPr>
+              <a:t>utt</a:t>
+            </a:r>
+            <a:r>
+              <a:rPr sz="1100" b="0" dirty="0">
+                <a:solidFill>
+                  <a:srgbClr val="97A6BA"/>
+                </a:solidFill>
+                <a:latin typeface="Arial"/>
+              </a:rPr>
+              <a:t> → audio</a:t>
             </a:r>
           </a:p>
         </p:txBody>
@@ -11480,12 +11934,6 @@
               </a:rPr>
               <a:t>Speech-to-speech: Nova 2 Sonic — 1 model, &lt; 3s/turn, barge-in</a:t>
             </a:r>
-            <a:endParaRPr sz="1400" b="1" dirty="0">
-              <a:solidFill>
-                <a:srgbClr val="8C4FFF"/>
-              </a:solidFill>
-              <a:latin typeface="Arial"/>
-            </a:endParaRPr>
           </a:p>
           <a:p>
             <a:pPr algn="l">
@@ -11502,12 +11950,6 @@
               </a:rPr>
               <a:t>Tool calling + RAG: Sonic gọi lookup_product → KB → S3 Vectors</a:t>
             </a:r>
-            <a:endParaRPr sz="1400" b="1" dirty="0">
-              <a:solidFill>
-                <a:srgbClr val="8C4FFF"/>
-              </a:solidFill>
-              <a:latin typeface="Arial"/>
-            </a:endParaRPr>
           </a:p>
           <a:p>
             <a:pPr algn="l">
@@ -11524,12 +11966,6 @@
               </a:rPr>
               <a:t>Pipecat: lo audio frame, barge-in, rotate stream — 1 ngày là chạy</a:t>
             </a:r>
-            <a:endParaRPr sz="1400" b="1" dirty="0">
-              <a:solidFill>
-                <a:srgbClr val="8C4FFF"/>
-              </a:solidFill>
-              <a:latin typeface="Arial"/>
-            </a:endParaRPr>
           </a:p>
         </p:txBody>
       </p:sp>
@@ -17079,8 +17515,8 @@
         </p:nvSpPr>
         <p:spPr>
           <a:xfrm>
-            <a:off x="640080" y="365760"/>
-            <a:ext cx="11247120" cy="731520"/>
+            <a:off x="640080" y="472026"/>
+            <a:ext cx="11247120" cy="518988"/>
           </a:xfrm>
           <a:prstGeom prst="rect">
             <a:avLst/>
@@ -17099,13 +17535,13 @@
               </a:lnSpc>
             </a:pPr>
             <a:r>
-              <a:rPr sz="3200" b="1">
+              <a:rPr sz="3200" b="1" dirty="0">
                 <a:solidFill>
                   <a:srgbClr val="FFFFFF"/>
                 </a:solidFill>
                 <a:latin typeface="Trebuchet MS"/>
               </a:rPr>
-              <a:t>AWS services dùng trong v1</a:t>
+              <a:t>AWS services</a:t>
             </a:r>
           </a:p>
         </p:txBody>
@@ -17119,7 +17555,7 @@
         <p:spPr>
           <a:xfrm>
             <a:off x="640080" y="1005840"/>
-            <a:ext cx="11247120" cy="365760"/>
+            <a:ext cx="11247120" cy="226665"/>
           </a:xfrm>
           <a:prstGeom prst="rect">
             <a:avLst/>
@@ -17138,13 +17574,31 @@
               </a:lnSpc>
             </a:pPr>
             <a:r>
-              <a:rPr sz="1400" b="0">
+              <a:rPr sz="1400" b="0" dirty="0">
                 <a:solidFill>
                   <a:srgbClr val="97A6BA"/>
                 </a:solidFill>
                 <a:latin typeface="Arial"/>
               </a:rPr>
-              <a:t>Core: Bedrock · AgentCore · KB + S3 Vectors · Langfuse · serverless</a:t>
+              <a:t>Core: Bedrock · </a:t>
+            </a:r>
+            <a:r>
+              <a:rPr sz="1400" b="0" dirty="0" err="1">
+                <a:solidFill>
+                  <a:srgbClr val="97A6BA"/>
+                </a:solidFill>
+                <a:latin typeface="Arial"/>
+              </a:rPr>
+              <a:t>AgentCore</a:t>
+            </a:r>
+            <a:r>
+              <a:rPr sz="1400" b="0" dirty="0">
+                <a:solidFill>
+                  <a:srgbClr val="97A6BA"/>
+                </a:solidFill>
+                <a:latin typeface="Arial"/>
+              </a:rPr>
+              <a:t> · KB + S3 Vectors  · serverless</a:t>
             </a:r>
           </a:p>
         </p:txBody>
@@ -17198,302 +17652,6 @@
       <p:pic>
         <p:nvPicPr>
           <p:cNvPr id="7" name="Picture 6" descr="bedrock.png"/>
-          <p:cNvPicPr>
-            <a:picLocks noChangeAspect="1"/>
-          </p:cNvPicPr>
-          <p:nvPr/>
-        </p:nvPicPr>
-        <p:blipFill>
-          <a:blip r:embed="rId2"/>
-          <a:stretch>
-            <a:fillRect/>
-          </a:stretch>
-        </p:blipFill>
-        <p:spPr>
-          <a:xfrm>
-            <a:off x="868680" y="2034540"/>
-            <a:ext cx="822960" cy="822960"/>
-          </a:xfrm>
-          <a:prstGeom prst="rect">
-            <a:avLst/>
-          </a:prstGeom>
-        </p:spPr>
-      </p:pic>
-      <p:sp>
-        <p:nvSpPr>
-          <p:cNvPr id="8" name="TextBox 7"/>
-          <p:cNvSpPr txBox="1"/>
-          <p:nvPr/>
-        </p:nvSpPr>
-        <p:spPr>
-          <a:xfrm>
-            <a:off x="1828800" y="2039112"/>
-            <a:ext cx="2331720" cy="457200"/>
-          </a:xfrm>
-          <a:prstGeom prst="rect">
-            <a:avLst/>
-          </a:prstGeom>
-          <a:noFill/>
-        </p:spPr>
-        <p:txBody>
-          <a:bodyPr wrap="square" lIns="0" tIns="0" rIns="0" bIns="0" anchor="t">
-            <a:spAutoFit/>
-          </a:bodyPr>
-          <a:lstStyle/>
-          <a:p>
-            <a:pPr algn="l">
-              <a:lnSpc>
-                <a:spcPct val="115000"/>
-              </a:lnSpc>
-            </a:pPr>
-            <a:r>
-              <a:rPr sz="1600" b="1">
-                <a:solidFill>
-                  <a:srgbClr val="FFFFFF"/>
-                </a:solidFill>
-                <a:latin typeface="Trebuchet MS"/>
-              </a:rPr>
-              <a:t>Bedrock</a:t>
-            </a:r>
-          </a:p>
-        </p:txBody>
-      </p:sp>
-      <p:sp>
-        <p:nvSpPr>
-          <p:cNvPr id="9" name="TextBox 8"/>
-          <p:cNvSpPr txBox="1"/>
-          <p:nvPr/>
-        </p:nvSpPr>
-        <p:spPr>
-          <a:xfrm>
-            <a:off x="1828800" y="2496312"/>
-            <a:ext cx="2331720" cy="411480"/>
-          </a:xfrm>
-          <a:prstGeom prst="rect">
-            <a:avLst/>
-          </a:prstGeom>
-          <a:noFill/>
-        </p:spPr>
-        <p:txBody>
-          <a:bodyPr wrap="square" lIns="0" tIns="0" rIns="0" bIns="0" anchor="t">
-            <a:spAutoFit/>
-          </a:bodyPr>
-          <a:lstStyle/>
-          <a:p>
-            <a:pPr algn="l">
-              <a:lnSpc>
-                <a:spcPct val="115000"/>
-              </a:lnSpc>
-            </a:pPr>
-            <a:r>
-              <a:rPr sz="1100" b="0">
-                <a:solidFill>
-                  <a:srgbClr val="97A6BA"/>
-                </a:solidFill>
-                <a:latin typeface="Arial"/>
-              </a:rPr>
-              <a:t>Nova 2 Sonic</a:t>
-            </a:r>
-          </a:p>
-        </p:txBody>
-      </p:sp>
-      <p:sp>
-        <p:nvSpPr>
-          <p:cNvPr id="10" name="Rounded Rectangle 9"/>
-          <p:cNvSpPr/>
-          <p:nvPr/>
-        </p:nvSpPr>
-        <p:spPr>
-          <a:xfrm>
-            <a:off x="4343400" y="1783080"/>
-            <a:ext cx="3611880" cy="1325880"/>
-          </a:xfrm>
-          <a:prstGeom prst="roundRect">
-            <a:avLst>
-              <a:gd name="adj" fmla="val 5000"/>
-            </a:avLst>
-          </a:prstGeom>
-          <a:solidFill>
-            <a:srgbClr val="162033"/>
-          </a:solidFill>
-          <a:ln>
-            <a:noFill/>
-          </a:ln>
-        </p:spPr>
-        <p:style>
-          <a:lnRef idx="1">
-            <a:schemeClr val="accent1"/>
-          </a:lnRef>
-          <a:fillRef idx="3">
-            <a:schemeClr val="accent1"/>
-          </a:fillRef>
-          <a:effectRef idx="2">
-            <a:schemeClr val="accent1"/>
-          </a:effectRef>
-          <a:fontRef idx="minor">
-            <a:schemeClr val="lt1"/>
-          </a:fontRef>
-        </p:style>
-        <p:txBody>
-          <a:bodyPr rtlCol="0" anchor="ctr"/>
-          <a:lstStyle/>
-          <a:p>
-            <a:pPr algn="ctr"/>
-            <a:endParaRPr/>
-          </a:p>
-        </p:txBody>
-      </p:sp>
-      <p:pic>
-        <p:nvPicPr>
-          <p:cNvPr id="11" name="Picture 10" descr="bedrock.png"/>
-          <p:cNvPicPr>
-            <a:picLocks noChangeAspect="1"/>
-          </p:cNvPicPr>
-          <p:nvPr/>
-        </p:nvPicPr>
-        <p:blipFill>
-          <a:blip r:embed="rId2"/>
-          <a:stretch>
-            <a:fillRect/>
-          </a:stretch>
-        </p:blipFill>
-        <p:spPr>
-          <a:xfrm>
-            <a:off x="4572000" y="2034540"/>
-            <a:ext cx="822960" cy="822960"/>
-          </a:xfrm>
-          <a:prstGeom prst="rect">
-            <a:avLst/>
-          </a:prstGeom>
-        </p:spPr>
-      </p:pic>
-      <p:sp>
-        <p:nvSpPr>
-          <p:cNvPr id="12" name="TextBox 11"/>
-          <p:cNvSpPr txBox="1"/>
-          <p:nvPr/>
-        </p:nvSpPr>
-        <p:spPr>
-          <a:xfrm>
-            <a:off x="5532120" y="2039112"/>
-            <a:ext cx="2331720" cy="457200"/>
-          </a:xfrm>
-          <a:prstGeom prst="rect">
-            <a:avLst/>
-          </a:prstGeom>
-          <a:noFill/>
-        </p:spPr>
-        <p:txBody>
-          <a:bodyPr wrap="square" lIns="0" tIns="0" rIns="0" bIns="0" anchor="t">
-            <a:spAutoFit/>
-          </a:bodyPr>
-          <a:lstStyle/>
-          <a:p>
-            <a:pPr algn="l">
-              <a:lnSpc>
-                <a:spcPct val="115000"/>
-              </a:lnSpc>
-            </a:pPr>
-            <a:r>
-              <a:rPr sz="1600" b="1">
-                <a:solidFill>
-                  <a:srgbClr val="FFFFFF"/>
-                </a:solidFill>
-                <a:latin typeface="Trebuchet MS"/>
-              </a:rPr>
-              <a:t>Bedrock KB</a:t>
-            </a:r>
-          </a:p>
-        </p:txBody>
-      </p:sp>
-      <p:sp>
-        <p:nvSpPr>
-          <p:cNvPr id="13" name="TextBox 12"/>
-          <p:cNvSpPr txBox="1"/>
-          <p:nvPr/>
-        </p:nvSpPr>
-        <p:spPr>
-          <a:xfrm>
-            <a:off x="5532120" y="2496312"/>
-            <a:ext cx="2331720" cy="411480"/>
-          </a:xfrm>
-          <a:prstGeom prst="rect">
-            <a:avLst/>
-          </a:prstGeom>
-          <a:noFill/>
-        </p:spPr>
-        <p:txBody>
-          <a:bodyPr wrap="square" lIns="0" tIns="0" rIns="0" bIns="0" anchor="t">
-            <a:spAutoFit/>
-          </a:bodyPr>
-          <a:lstStyle/>
-          <a:p>
-            <a:pPr algn="l">
-              <a:lnSpc>
-                <a:spcPct val="115000"/>
-              </a:lnSpc>
-            </a:pPr>
-            <a:r>
-              <a:rPr sz="1100" b="0">
-                <a:solidFill>
-                  <a:srgbClr val="97A6BA"/>
-                </a:solidFill>
-                <a:latin typeface="Arial"/>
-              </a:rPr>
-              <a:t>+ S3 Vectors</a:t>
-            </a:r>
-          </a:p>
-        </p:txBody>
-      </p:sp>
-      <p:sp>
-        <p:nvSpPr>
-          <p:cNvPr id="14" name="Rounded Rectangle 13"/>
-          <p:cNvSpPr/>
-          <p:nvPr/>
-        </p:nvSpPr>
-        <p:spPr>
-          <a:xfrm>
-            <a:off x="8046720" y="1783080"/>
-            <a:ext cx="3611880" cy="1325880"/>
-          </a:xfrm>
-          <a:prstGeom prst="roundRect">
-            <a:avLst>
-              <a:gd name="adj" fmla="val 5000"/>
-            </a:avLst>
-          </a:prstGeom>
-          <a:solidFill>
-            <a:srgbClr val="162033"/>
-          </a:solidFill>
-          <a:ln>
-            <a:noFill/>
-          </a:ln>
-        </p:spPr>
-        <p:style>
-          <a:lnRef idx="1">
-            <a:schemeClr val="accent1"/>
-          </a:lnRef>
-          <a:fillRef idx="3">
-            <a:schemeClr val="accent1"/>
-          </a:fillRef>
-          <a:effectRef idx="2">
-            <a:schemeClr val="accent1"/>
-          </a:effectRef>
-          <a:fontRef idx="minor">
-            <a:schemeClr val="lt1"/>
-          </a:fontRef>
-        </p:style>
-        <p:txBody>
-          <a:bodyPr rtlCol="0" anchor="ctr"/>
-          <a:lstStyle/>
-          <a:p>
-            <a:pPr algn="ctr"/>
-            <a:endParaRPr/>
-          </a:p>
-        </p:txBody>
-      </p:sp>
-      <p:pic>
-        <p:nvPicPr>
-          <p:cNvPr id="15" name="Picture 14" descr="agentcore.png"/>
           <p:cNvPicPr>
             <a:picLocks noChangeAspect="1"/>
           </p:cNvPicPr>
@@ -17507,7 +17665,7 @@
         </p:blipFill>
         <p:spPr>
           <a:xfrm>
-            <a:off x="8275320" y="2034540"/>
+            <a:off x="868680" y="2034540"/>
             <a:ext cx="822960" cy="822960"/>
           </a:xfrm>
           <a:prstGeom prst="rect">
@@ -17517,13 +17675,13 @@
       </p:pic>
       <p:sp>
         <p:nvSpPr>
-          <p:cNvPr id="16" name="TextBox 15"/>
+          <p:cNvPr id="8" name="TextBox 7"/>
           <p:cNvSpPr txBox="1"/>
           <p:nvPr/>
         </p:nvSpPr>
         <p:spPr>
           <a:xfrm>
-            <a:off x="9235440" y="2039112"/>
+            <a:off x="1828800" y="2039112"/>
             <a:ext cx="2331720" cy="457200"/>
           </a:xfrm>
           <a:prstGeom prst="rect">
@@ -17543,26 +17701,26 @@
               </a:lnSpc>
             </a:pPr>
             <a:r>
-              <a:rPr sz="1600" b="1">
+              <a:rPr sz="1600" b="1" dirty="0">
                 <a:solidFill>
                   <a:srgbClr val="FFFFFF"/>
                 </a:solidFill>
                 <a:latin typeface="Trebuchet MS"/>
               </a:rPr>
-              <a:t>AgentCore</a:t>
-            </a:r>
-          </a:p>
-        </p:txBody>
-      </p:sp>
-      <p:sp>
-        <p:nvSpPr>
-          <p:cNvPr id="17" name="TextBox 16"/>
+              <a:t>Bedrock</a:t>
+            </a:r>
+          </a:p>
+        </p:txBody>
+      </p:sp>
+      <p:sp>
+        <p:nvSpPr>
+          <p:cNvPr id="9" name="TextBox 8"/>
           <p:cNvSpPr txBox="1"/>
           <p:nvPr/>
         </p:nvSpPr>
         <p:spPr>
           <a:xfrm>
-            <a:off x="9235440" y="2496312"/>
+            <a:off x="1828800" y="2496312"/>
             <a:ext cx="2331720" cy="411480"/>
           </a:xfrm>
           <a:prstGeom prst="rect">
@@ -17588,20 +17746,20 @@
                 </a:solidFill>
                 <a:latin typeface="Arial"/>
               </a:rPr>
-              <a:t>Runtime</a:t>
-            </a:r>
-          </a:p>
-        </p:txBody>
-      </p:sp>
-      <p:sp>
-        <p:nvSpPr>
-          <p:cNvPr id="18" name="Rounded Rectangle 17"/>
+              <a:t>Nova 2 Sonic</a:t>
+            </a:r>
+          </a:p>
+        </p:txBody>
+      </p:sp>
+      <p:sp>
+        <p:nvSpPr>
+          <p:cNvPr id="10" name="Rounded Rectangle 9"/>
           <p:cNvSpPr/>
           <p:nvPr/>
         </p:nvSpPr>
         <p:spPr>
           <a:xfrm>
-            <a:off x="640080" y="3218688"/>
+            <a:off x="4343400" y="1783080"/>
             <a:ext cx="3611880" cy="1325880"/>
           </a:xfrm>
           <a:prstGeom prst="roundRect">
@@ -17641,7 +17799,155 @@
       </p:sp>
       <p:pic>
         <p:nvPicPr>
-          <p:cNvPr id="19" name="Picture 18" descr="s3.png"/>
+          <p:cNvPr id="11" name="Picture 10" descr="bedrock.png"/>
+          <p:cNvPicPr>
+            <a:picLocks noChangeAspect="1"/>
+          </p:cNvPicPr>
+          <p:nvPr/>
+        </p:nvPicPr>
+        <p:blipFill>
+          <a:blip r:embed="rId3"/>
+          <a:stretch>
+            <a:fillRect/>
+          </a:stretch>
+        </p:blipFill>
+        <p:spPr>
+          <a:xfrm>
+            <a:off x="4572000" y="2034540"/>
+            <a:ext cx="822960" cy="822960"/>
+          </a:xfrm>
+          <a:prstGeom prst="rect">
+            <a:avLst/>
+          </a:prstGeom>
+        </p:spPr>
+      </p:pic>
+      <p:sp>
+        <p:nvSpPr>
+          <p:cNvPr id="12" name="TextBox 11"/>
+          <p:cNvSpPr txBox="1"/>
+          <p:nvPr/>
+        </p:nvSpPr>
+        <p:spPr>
+          <a:xfrm>
+            <a:off x="5532120" y="2039112"/>
+            <a:ext cx="2331720" cy="457200"/>
+          </a:xfrm>
+          <a:prstGeom prst="rect">
+            <a:avLst/>
+          </a:prstGeom>
+          <a:noFill/>
+        </p:spPr>
+        <p:txBody>
+          <a:bodyPr wrap="square" lIns="0" tIns="0" rIns="0" bIns="0" anchor="t">
+            <a:spAutoFit/>
+          </a:bodyPr>
+          <a:lstStyle/>
+          <a:p>
+            <a:pPr algn="l">
+              <a:lnSpc>
+                <a:spcPct val="115000"/>
+              </a:lnSpc>
+            </a:pPr>
+            <a:r>
+              <a:rPr sz="1600" b="1">
+                <a:solidFill>
+                  <a:srgbClr val="FFFFFF"/>
+                </a:solidFill>
+                <a:latin typeface="Trebuchet MS"/>
+              </a:rPr>
+              <a:t>Bedrock KB</a:t>
+            </a:r>
+          </a:p>
+        </p:txBody>
+      </p:sp>
+      <p:sp>
+        <p:nvSpPr>
+          <p:cNvPr id="13" name="TextBox 12"/>
+          <p:cNvSpPr txBox="1"/>
+          <p:nvPr/>
+        </p:nvSpPr>
+        <p:spPr>
+          <a:xfrm>
+            <a:off x="5532120" y="2496312"/>
+            <a:ext cx="2331720" cy="411480"/>
+          </a:xfrm>
+          <a:prstGeom prst="rect">
+            <a:avLst/>
+          </a:prstGeom>
+          <a:noFill/>
+        </p:spPr>
+        <p:txBody>
+          <a:bodyPr wrap="square" lIns="0" tIns="0" rIns="0" bIns="0" anchor="t">
+            <a:spAutoFit/>
+          </a:bodyPr>
+          <a:lstStyle/>
+          <a:p>
+            <a:pPr algn="l">
+              <a:lnSpc>
+                <a:spcPct val="115000"/>
+              </a:lnSpc>
+            </a:pPr>
+            <a:r>
+              <a:rPr sz="1100" b="0">
+                <a:solidFill>
+                  <a:srgbClr val="97A6BA"/>
+                </a:solidFill>
+                <a:latin typeface="Arial"/>
+              </a:rPr>
+              <a:t>+ S3 Vectors</a:t>
+            </a:r>
+          </a:p>
+        </p:txBody>
+      </p:sp>
+      <p:sp>
+        <p:nvSpPr>
+          <p:cNvPr id="14" name="Rounded Rectangle 13"/>
+          <p:cNvSpPr/>
+          <p:nvPr/>
+        </p:nvSpPr>
+        <p:spPr>
+          <a:xfrm>
+            <a:off x="8046720" y="1783080"/>
+            <a:ext cx="3611880" cy="1325880"/>
+          </a:xfrm>
+          <a:prstGeom prst="roundRect">
+            <a:avLst>
+              <a:gd name="adj" fmla="val 5000"/>
+            </a:avLst>
+          </a:prstGeom>
+          <a:solidFill>
+            <a:srgbClr val="162033"/>
+          </a:solidFill>
+          <a:ln>
+            <a:noFill/>
+          </a:ln>
+        </p:spPr>
+        <p:style>
+          <a:lnRef idx="1">
+            <a:schemeClr val="accent1"/>
+          </a:lnRef>
+          <a:fillRef idx="3">
+            <a:schemeClr val="accent1"/>
+          </a:fillRef>
+          <a:effectRef idx="2">
+            <a:schemeClr val="accent1"/>
+          </a:effectRef>
+          <a:fontRef idx="minor">
+            <a:schemeClr val="lt1"/>
+          </a:fontRef>
+        </p:style>
+        <p:txBody>
+          <a:bodyPr rtlCol="0" anchor="ctr"/>
+          <a:lstStyle/>
+          <a:p>
+            <a:pPr algn="ctr"/>
+            <a:endParaRPr/>
+          </a:p>
+        </p:txBody>
+      </p:sp>
+      <p:pic>
+        <p:nvPicPr>
+          <p:cNvPr id="15" name="Picture 14" descr="agentcore.png"/>
           <p:cNvPicPr>
             <a:picLocks noChangeAspect="1"/>
           </p:cNvPicPr>
@@ -17655,7 +17961,7 @@
         </p:blipFill>
         <p:spPr>
           <a:xfrm>
-            <a:off x="868680" y="3470148"/>
+            <a:off x="8275320" y="2034540"/>
             <a:ext cx="822960" cy="822960"/>
           </a:xfrm>
           <a:prstGeom prst="rect">
@@ -17665,13 +17971,13 @@
       </p:pic>
       <p:sp>
         <p:nvSpPr>
-          <p:cNvPr id="20" name="TextBox 19"/>
+          <p:cNvPr id="16" name="TextBox 15"/>
           <p:cNvSpPr txBox="1"/>
           <p:nvPr/>
         </p:nvSpPr>
         <p:spPr>
           <a:xfrm>
-            <a:off x="1828800" y="3474720"/>
+            <a:off x="9235440" y="2039112"/>
             <a:ext cx="2331720" cy="457200"/>
           </a:xfrm>
           <a:prstGeom prst="rect">
@@ -17697,20 +18003,20 @@
                 </a:solidFill>
                 <a:latin typeface="Trebuchet MS"/>
               </a:rPr>
-              <a:t>S3</a:t>
-            </a:r>
-          </a:p>
-        </p:txBody>
-      </p:sp>
-      <p:sp>
-        <p:nvSpPr>
-          <p:cNvPr id="21" name="TextBox 20"/>
+              <a:t>AgentCore</a:t>
+            </a:r>
+          </a:p>
+        </p:txBody>
+      </p:sp>
+      <p:sp>
+        <p:nvSpPr>
+          <p:cNvPr id="17" name="TextBox 16"/>
           <p:cNvSpPr txBox="1"/>
           <p:nvPr/>
         </p:nvSpPr>
         <p:spPr>
           <a:xfrm>
-            <a:off x="1828800" y="3931920"/>
+            <a:off x="9235440" y="2496312"/>
             <a:ext cx="2331720" cy="411480"/>
           </a:xfrm>
           <a:prstGeom prst="rect">
@@ -17736,20 +18042,20 @@
                 </a:solidFill>
                 <a:latin typeface="Arial"/>
               </a:rPr>
-              <a:t>Widget + KB src</a:t>
-            </a:r>
-          </a:p>
-        </p:txBody>
-      </p:sp>
-      <p:sp>
-        <p:nvSpPr>
-          <p:cNvPr id="22" name="Rounded Rectangle 21"/>
+              <a:t>Runtime</a:t>
+            </a:r>
+          </a:p>
+        </p:txBody>
+      </p:sp>
+      <p:sp>
+        <p:nvSpPr>
+          <p:cNvPr id="18" name="Rounded Rectangle 17"/>
           <p:cNvSpPr/>
           <p:nvPr/>
         </p:nvSpPr>
         <p:spPr>
           <a:xfrm>
-            <a:off x="4343400" y="3218688"/>
+            <a:off x="640080" y="3218688"/>
             <a:ext cx="3611880" cy="1325880"/>
           </a:xfrm>
           <a:prstGeom prst="roundRect">
@@ -17789,7 +18095,7 @@
       </p:sp>
       <p:pic>
         <p:nvPicPr>
-          <p:cNvPr id="23" name="Picture 22" descr="cloudfront.png"/>
+          <p:cNvPr id="19" name="Picture 18" descr="s3.png"/>
           <p:cNvPicPr>
             <a:picLocks noChangeAspect="1"/>
           </p:cNvPicPr>
@@ -17803,7 +18109,7 @@
         </p:blipFill>
         <p:spPr>
           <a:xfrm>
-            <a:off x="4572000" y="3470148"/>
+            <a:off x="868680" y="3470148"/>
             <a:ext cx="822960" cy="822960"/>
           </a:xfrm>
           <a:prstGeom prst="rect">
@@ -17813,13 +18119,13 @@
       </p:pic>
       <p:sp>
         <p:nvSpPr>
-          <p:cNvPr id="24" name="TextBox 23"/>
+          <p:cNvPr id="20" name="TextBox 19"/>
           <p:cNvSpPr txBox="1"/>
           <p:nvPr/>
         </p:nvSpPr>
         <p:spPr>
           <a:xfrm>
-            <a:off x="5532120" y="3474720"/>
+            <a:off x="1828800" y="3474720"/>
             <a:ext cx="2331720" cy="457200"/>
           </a:xfrm>
           <a:prstGeom prst="rect">
@@ -17845,20 +18151,20 @@
                 </a:solidFill>
                 <a:latin typeface="Trebuchet MS"/>
               </a:rPr>
-              <a:t>CloudFront</a:t>
-            </a:r>
-          </a:p>
-        </p:txBody>
-      </p:sp>
-      <p:sp>
-        <p:nvSpPr>
-          <p:cNvPr id="25" name="TextBox 24"/>
+              <a:t>S3</a:t>
+            </a:r>
+          </a:p>
+        </p:txBody>
+      </p:sp>
+      <p:sp>
+        <p:nvSpPr>
+          <p:cNvPr id="21" name="TextBox 20"/>
           <p:cNvSpPr txBox="1"/>
           <p:nvPr/>
         </p:nvSpPr>
         <p:spPr>
           <a:xfrm>
-            <a:off x="5532120" y="3931920"/>
+            <a:off x="1828800" y="3931920"/>
             <a:ext cx="2331720" cy="411480"/>
           </a:xfrm>
           <a:prstGeom prst="rect">
@@ -17884,20 +18190,20 @@
                 </a:solidFill>
                 <a:latin typeface="Arial"/>
               </a:rPr>
-              <a:t>HTTPS edge + OAC</a:t>
-            </a:r>
-          </a:p>
-        </p:txBody>
-      </p:sp>
-      <p:sp>
-        <p:nvSpPr>
-          <p:cNvPr id="26" name="Rounded Rectangle 25"/>
+              <a:t>Widget + KB src</a:t>
+            </a:r>
+          </a:p>
+        </p:txBody>
+      </p:sp>
+      <p:sp>
+        <p:nvSpPr>
+          <p:cNvPr id="22" name="Rounded Rectangle 21"/>
           <p:cNvSpPr/>
           <p:nvPr/>
         </p:nvSpPr>
         <p:spPr>
           <a:xfrm>
-            <a:off x="8046720" y="3218688"/>
+            <a:off x="4343400" y="3218688"/>
             <a:ext cx="3611880" cy="1325880"/>
           </a:xfrm>
           <a:prstGeom prst="roundRect">
@@ -17937,7 +18243,7 @@
       </p:sp>
       <p:pic>
         <p:nvPicPr>
-          <p:cNvPr id="27" name="Picture 26" descr="lambda.png"/>
+          <p:cNvPr id="23" name="Picture 22" descr="cloudfront.png"/>
           <p:cNvPicPr>
             <a:picLocks noChangeAspect="1"/>
           </p:cNvPicPr>
@@ -17951,7 +18257,7 @@
         </p:blipFill>
         <p:spPr>
           <a:xfrm>
-            <a:off x="8275320" y="3470148"/>
+            <a:off x="4572000" y="3470148"/>
             <a:ext cx="822960" cy="822960"/>
           </a:xfrm>
           <a:prstGeom prst="rect">
@@ -17961,13 +18267,13 @@
       </p:pic>
       <p:sp>
         <p:nvSpPr>
-          <p:cNvPr id="28" name="TextBox 27"/>
+          <p:cNvPr id="24" name="TextBox 23"/>
           <p:cNvSpPr txBox="1"/>
           <p:nvPr/>
         </p:nvSpPr>
         <p:spPr>
           <a:xfrm>
-            <a:off x="9235440" y="3474720"/>
+            <a:off x="5532120" y="3474720"/>
             <a:ext cx="2331720" cy="457200"/>
           </a:xfrm>
           <a:prstGeom prst="rect">
@@ -17993,20 +18299,20 @@
                 </a:solidFill>
                 <a:latin typeface="Trebuchet MS"/>
               </a:rPr>
-              <a:t>Lambda</a:t>
-            </a:r>
-          </a:p>
-        </p:txBody>
-      </p:sp>
-      <p:sp>
-        <p:nvSpPr>
-          <p:cNvPr id="29" name="TextBox 28"/>
+              <a:t>CloudFront</a:t>
+            </a:r>
+          </a:p>
+        </p:txBody>
+      </p:sp>
+      <p:sp>
+        <p:nvSpPr>
+          <p:cNvPr id="25" name="TextBox 24"/>
           <p:cNvSpPr txBox="1"/>
           <p:nvPr/>
         </p:nvSpPr>
         <p:spPr>
           <a:xfrm>
-            <a:off x="9235440" y="3931920"/>
+            <a:off x="5532120" y="3931920"/>
             <a:ext cx="2331720" cy="411480"/>
           </a:xfrm>
           <a:prstGeom prst="rect">
@@ -18032,20 +18338,20 @@
                 </a:solidFill>
                 <a:latin typeface="Arial"/>
               </a:rPr>
-              <a:t>SigV4 presigner</a:t>
-            </a:r>
-          </a:p>
-        </p:txBody>
-      </p:sp>
-      <p:sp>
-        <p:nvSpPr>
-          <p:cNvPr id="30" name="Rounded Rectangle 29"/>
+              <a:t>HTTPS edge + OAC</a:t>
+            </a:r>
+          </a:p>
+        </p:txBody>
+      </p:sp>
+      <p:sp>
+        <p:nvSpPr>
+          <p:cNvPr id="26" name="Rounded Rectangle 25"/>
           <p:cNvSpPr/>
           <p:nvPr/>
         </p:nvSpPr>
         <p:spPr>
           <a:xfrm>
-            <a:off x="640080" y="4654296"/>
+            <a:off x="8046720" y="3218688"/>
             <a:ext cx="3611880" cy="1325880"/>
           </a:xfrm>
           <a:prstGeom prst="roundRect">
@@ -18085,7 +18391,7 @@
       </p:sp>
       <p:pic>
         <p:nvPicPr>
-          <p:cNvPr id="31" name="Picture 30" descr="ecr.png"/>
+          <p:cNvPr id="27" name="Picture 26" descr="lambda.png"/>
           <p:cNvPicPr>
             <a:picLocks noChangeAspect="1"/>
           </p:cNvPicPr>
@@ -18099,7 +18405,7 @@
         </p:blipFill>
         <p:spPr>
           <a:xfrm>
-            <a:off x="868680" y="4905756"/>
+            <a:off x="8275320" y="3470148"/>
             <a:ext cx="822960" cy="822960"/>
           </a:xfrm>
           <a:prstGeom prst="rect">
@@ -18109,53 +18415,85 @@
       </p:pic>
       <p:sp>
         <p:nvSpPr>
-          <p:cNvPr id="34" name="Rounded Rectangle 33"/>
-          <p:cNvSpPr/>
-          <p:nvPr/>
-        </p:nvSpPr>
-        <p:spPr>
-          <a:xfrm>
-            <a:off x="4343400" y="4654296"/>
-            <a:ext cx="3611880" cy="1325880"/>
-          </a:xfrm>
-          <a:prstGeom prst="roundRect">
-            <a:avLst>
-              <a:gd name="adj" fmla="val 5000"/>
-            </a:avLst>
-          </a:prstGeom>
-          <a:solidFill>
-            <a:srgbClr val="162033"/>
-          </a:solidFill>
-          <a:ln>
-            <a:noFill/>
-          </a:ln>
-        </p:spPr>
-        <p:style>
-          <a:lnRef idx="1">
-            <a:schemeClr val="accent1"/>
-          </a:lnRef>
-          <a:fillRef idx="3">
-            <a:schemeClr val="accent1"/>
-          </a:fillRef>
-          <a:effectRef idx="2">
-            <a:schemeClr val="accent1"/>
-          </a:effectRef>
-          <a:fontRef idx="minor">
-            <a:schemeClr val="lt1"/>
-          </a:fontRef>
-        </p:style>
-        <p:txBody>
-          <a:bodyPr rtlCol="0" anchor="ctr"/>
-          <a:lstStyle/>
-          <a:p>
-            <a:pPr algn="ctr"/>
-            <a:endParaRPr/>
+          <p:cNvPr id="28" name="TextBox 27"/>
+          <p:cNvSpPr txBox="1"/>
+          <p:nvPr/>
+        </p:nvSpPr>
+        <p:spPr>
+          <a:xfrm>
+            <a:off x="9235440" y="3474720"/>
+            <a:ext cx="2331720" cy="457200"/>
+          </a:xfrm>
+          <a:prstGeom prst="rect">
+            <a:avLst/>
+          </a:prstGeom>
+          <a:noFill/>
+        </p:spPr>
+        <p:txBody>
+          <a:bodyPr wrap="square" lIns="0" tIns="0" rIns="0" bIns="0" anchor="t">
+            <a:spAutoFit/>
+          </a:bodyPr>
+          <a:lstStyle/>
+          <a:p>
+            <a:pPr algn="l">
+              <a:lnSpc>
+                <a:spcPct val="115000"/>
+              </a:lnSpc>
+            </a:pPr>
+            <a:r>
+              <a:rPr sz="1600" b="1">
+                <a:solidFill>
+                  <a:srgbClr val="FFFFFF"/>
+                </a:solidFill>
+                <a:latin typeface="Trebuchet MS"/>
+              </a:rPr>
+              <a:t>Lambda</a:t>
+            </a:r>
+          </a:p>
+        </p:txBody>
+      </p:sp>
+      <p:sp>
+        <p:nvSpPr>
+          <p:cNvPr id="29" name="TextBox 28"/>
+          <p:cNvSpPr txBox="1"/>
+          <p:nvPr/>
+        </p:nvSpPr>
+        <p:spPr>
+          <a:xfrm>
+            <a:off x="9235440" y="3931920"/>
+            <a:ext cx="2331720" cy="411480"/>
+          </a:xfrm>
+          <a:prstGeom prst="rect">
+            <a:avLst/>
+          </a:prstGeom>
+          <a:noFill/>
+        </p:spPr>
+        <p:txBody>
+          <a:bodyPr wrap="square" lIns="0" tIns="0" rIns="0" bIns="0" anchor="t">
+            <a:spAutoFit/>
+          </a:bodyPr>
+          <a:lstStyle/>
+          <a:p>
+            <a:pPr algn="l">
+              <a:lnSpc>
+                <a:spcPct val="115000"/>
+              </a:lnSpc>
+            </a:pPr>
+            <a:r>
+              <a:rPr sz="1100" b="0">
+                <a:solidFill>
+                  <a:srgbClr val="97A6BA"/>
+                </a:solidFill>
+                <a:latin typeface="Arial"/>
+              </a:rPr>
+              <a:t>SigV4 presigner</a:t>
+            </a:r>
           </a:p>
         </p:txBody>
       </p:sp>
       <p:pic>
         <p:nvPicPr>
-          <p:cNvPr id="35" name="Picture 34" descr="iam.png"/>
+          <p:cNvPr id="42" name="Picture 41" descr="fcj-logo-lockup.png"/>
           <p:cNvPicPr>
             <a:picLocks noChangeAspect="1"/>
           </p:cNvPicPr>
@@ -18169,100 +18507,6 @@
         </p:blipFill>
         <p:spPr>
           <a:xfrm>
-            <a:off x="4572000" y="4905756"/>
-            <a:ext cx="822960" cy="822960"/>
-          </a:xfrm>
-          <a:prstGeom prst="rect">
-            <a:avLst/>
-          </a:prstGeom>
-        </p:spPr>
-      </p:pic>
-      <p:sp>
-        <p:nvSpPr>
-          <p:cNvPr id="38" name="Rounded Rectangle 37"/>
-          <p:cNvSpPr/>
-          <p:nvPr/>
-        </p:nvSpPr>
-        <p:spPr>
-          <a:xfrm>
-            <a:off x="8046720" y="4654296"/>
-            <a:ext cx="3611880" cy="1325880"/>
-          </a:xfrm>
-          <a:prstGeom prst="roundRect">
-            <a:avLst>
-              <a:gd name="adj" fmla="val 5000"/>
-            </a:avLst>
-          </a:prstGeom>
-          <a:solidFill>
-            <a:srgbClr val="162033"/>
-          </a:solidFill>
-          <a:ln>
-            <a:noFill/>
-          </a:ln>
-        </p:spPr>
-        <p:style>
-          <a:lnRef idx="1">
-            <a:schemeClr val="accent1"/>
-          </a:lnRef>
-          <a:fillRef idx="3">
-            <a:schemeClr val="accent1"/>
-          </a:fillRef>
-          <a:effectRef idx="2">
-            <a:schemeClr val="accent1"/>
-          </a:effectRef>
-          <a:fontRef idx="minor">
-            <a:schemeClr val="lt1"/>
-          </a:fontRef>
-        </p:style>
-        <p:txBody>
-          <a:bodyPr rtlCol="0" anchor="ctr"/>
-          <a:lstStyle/>
-          <a:p>
-            <a:pPr algn="ctr"/>
-            <a:endParaRPr/>
-          </a:p>
-        </p:txBody>
-      </p:sp>
-      <p:pic>
-        <p:nvPicPr>
-          <p:cNvPr id="39" name="Picture 38" descr="cloudwatch.png"/>
-          <p:cNvPicPr>
-            <a:picLocks noChangeAspect="1"/>
-          </p:cNvPicPr>
-          <p:nvPr/>
-        </p:nvPicPr>
-        <p:blipFill>
-          <a:blip r:embed="rId9"/>
-          <a:stretch>
-            <a:fillRect/>
-          </a:stretch>
-        </p:blipFill>
-        <p:spPr>
-          <a:xfrm>
-            <a:off x="8275320" y="4905756"/>
-            <a:ext cx="822960" cy="822960"/>
-          </a:xfrm>
-          <a:prstGeom prst="rect">
-            <a:avLst/>
-          </a:prstGeom>
-        </p:spPr>
-      </p:pic>
-      <p:pic>
-        <p:nvPicPr>
-          <p:cNvPr id="42" name="Picture 41" descr="fcj-logo-lockup.png"/>
-          <p:cNvPicPr>
-            <a:picLocks noChangeAspect="1"/>
-          </p:cNvPicPr>
-          <p:nvPr/>
-        </p:nvPicPr>
-        <p:blipFill>
-          <a:blip r:embed="rId10"/>
-          <a:stretch>
-            <a:fillRect/>
-          </a:stretch>
-        </p:blipFill>
-        <p:spPr>
-          <a:xfrm>
             <a:off x="411480" y="6355080"/>
             <a:ext cx="1417320" cy="384048"/>
           </a:xfrm>
@@ -18315,6 +18559,812 @@
   <p:clrMapOvr>
     <a:masterClrMapping/>
   </p:clrMapOvr>
+  <p:timing>
+    <p:tnLst>
+      <p:par>
+        <p:cTn id="1" dur="indefinite" restart="never" nodeType="tmRoot">
+          <p:childTnLst>
+            <p:seq concurrent="1" nextAc="seek">
+              <p:cTn id="2" dur="indefinite" nodeType="mainSeq">
+                <p:childTnLst>
+                  <p:par>
+                    <p:cTn id="3" fill="hold">
+                      <p:stCondLst>
+                        <p:cond delay="indefinite"/>
+                      </p:stCondLst>
+                      <p:childTnLst>
+                        <p:par>
+                          <p:cTn id="4" fill="hold">
+                            <p:stCondLst>
+                              <p:cond delay="0"/>
+                            </p:stCondLst>
+                            <p:childTnLst>
+                              <p:par>
+                                <p:cTn id="5" presetID="1" presetClass="entr" presetSubtype="0" fill="hold" grpId="0" nodeType="clickEffect">
+                                  <p:stCondLst>
+                                    <p:cond delay="0"/>
+                                  </p:stCondLst>
+                                  <p:childTnLst>
+                                    <p:set>
+                                      <p:cBhvr>
+                                        <p:cTn id="6" dur="1" fill="hold">
+                                          <p:stCondLst>
+                                            <p:cond delay="0"/>
+                                          </p:stCondLst>
+                                        </p:cTn>
+                                        <p:tgtEl>
+                                          <p:spTgt spid="8"/>
+                                        </p:tgtEl>
+                                        <p:attrNameLst>
+                                          <p:attrName>style.visibility</p:attrName>
+                                        </p:attrNameLst>
+                                      </p:cBhvr>
+                                      <p:to>
+                                        <p:strVal val="visible"/>
+                                      </p:to>
+                                    </p:set>
+                                  </p:childTnLst>
+                                </p:cTn>
+                              </p:par>
+                              <p:par>
+                                <p:cTn id="7" presetID="1" presetClass="entr" presetSubtype="0" fill="hold" grpId="0" nodeType="withEffect">
+                                  <p:stCondLst>
+                                    <p:cond delay="0"/>
+                                  </p:stCondLst>
+                                  <p:childTnLst>
+                                    <p:set>
+                                      <p:cBhvr>
+                                        <p:cTn id="8" dur="1" fill="hold">
+                                          <p:stCondLst>
+                                            <p:cond delay="0"/>
+                                          </p:stCondLst>
+                                        </p:cTn>
+                                        <p:tgtEl>
+                                          <p:spTgt spid="9"/>
+                                        </p:tgtEl>
+                                        <p:attrNameLst>
+                                          <p:attrName>style.visibility</p:attrName>
+                                        </p:attrNameLst>
+                                      </p:cBhvr>
+                                      <p:to>
+                                        <p:strVal val="visible"/>
+                                      </p:to>
+                                    </p:set>
+                                  </p:childTnLst>
+                                </p:cTn>
+                              </p:par>
+                              <p:par>
+                                <p:cTn id="9" presetID="1" presetClass="entr" presetSubtype="0" fill="hold" nodeType="withEffect">
+                                  <p:stCondLst>
+                                    <p:cond delay="0"/>
+                                  </p:stCondLst>
+                                  <p:childTnLst>
+                                    <p:set>
+                                      <p:cBhvr>
+                                        <p:cTn id="10" dur="1" fill="hold">
+                                          <p:stCondLst>
+                                            <p:cond delay="0"/>
+                                          </p:stCondLst>
+                                        </p:cTn>
+                                        <p:tgtEl>
+                                          <p:spTgt spid="7"/>
+                                        </p:tgtEl>
+                                        <p:attrNameLst>
+                                          <p:attrName>style.visibility</p:attrName>
+                                        </p:attrNameLst>
+                                      </p:cBhvr>
+                                      <p:to>
+                                        <p:strVal val="visible"/>
+                                      </p:to>
+                                    </p:set>
+                                  </p:childTnLst>
+                                </p:cTn>
+                              </p:par>
+                              <p:par>
+                                <p:cTn id="11" presetID="1" presetClass="entr" presetSubtype="0" fill="hold" grpId="0" nodeType="withEffect">
+                                  <p:stCondLst>
+                                    <p:cond delay="0"/>
+                                  </p:stCondLst>
+                                  <p:childTnLst>
+                                    <p:set>
+                                      <p:cBhvr>
+                                        <p:cTn id="12" dur="1" fill="hold">
+                                          <p:stCondLst>
+                                            <p:cond delay="0"/>
+                                          </p:stCondLst>
+                                        </p:cTn>
+                                        <p:tgtEl>
+                                          <p:spTgt spid="6"/>
+                                        </p:tgtEl>
+                                        <p:attrNameLst>
+                                          <p:attrName>style.visibility</p:attrName>
+                                        </p:attrNameLst>
+                                      </p:cBhvr>
+                                      <p:to>
+                                        <p:strVal val="visible"/>
+                                      </p:to>
+                                    </p:set>
+                                  </p:childTnLst>
+                                </p:cTn>
+                              </p:par>
+                            </p:childTnLst>
+                          </p:cTn>
+                        </p:par>
+                      </p:childTnLst>
+                    </p:cTn>
+                  </p:par>
+                  <p:par>
+                    <p:cTn id="13" fill="hold">
+                      <p:stCondLst>
+                        <p:cond delay="indefinite"/>
+                      </p:stCondLst>
+                      <p:childTnLst>
+                        <p:par>
+                          <p:cTn id="14" fill="hold">
+                            <p:stCondLst>
+                              <p:cond delay="0"/>
+                            </p:stCondLst>
+                            <p:childTnLst>
+                              <p:par>
+                                <p:cTn id="15" presetID="1" presetClass="entr" presetSubtype="0" fill="hold" grpId="0" nodeType="clickEffect">
+                                  <p:stCondLst>
+                                    <p:cond delay="0"/>
+                                  </p:stCondLst>
+                                  <p:childTnLst>
+                                    <p:set>
+                                      <p:cBhvr>
+                                        <p:cTn id="16" dur="1" fill="hold">
+                                          <p:stCondLst>
+                                            <p:cond delay="0"/>
+                                          </p:stCondLst>
+                                        </p:cTn>
+                                        <p:tgtEl>
+                                          <p:spTgt spid="13"/>
+                                        </p:tgtEl>
+                                        <p:attrNameLst>
+                                          <p:attrName>style.visibility</p:attrName>
+                                        </p:attrNameLst>
+                                      </p:cBhvr>
+                                      <p:to>
+                                        <p:strVal val="visible"/>
+                                      </p:to>
+                                    </p:set>
+                                  </p:childTnLst>
+                                </p:cTn>
+                              </p:par>
+                              <p:par>
+                                <p:cTn id="17" presetID="1" presetClass="entr" presetSubtype="0" fill="hold" grpId="0" nodeType="withEffect">
+                                  <p:stCondLst>
+                                    <p:cond delay="0"/>
+                                  </p:stCondLst>
+                                  <p:childTnLst>
+                                    <p:set>
+                                      <p:cBhvr>
+                                        <p:cTn id="18" dur="1" fill="hold">
+                                          <p:stCondLst>
+                                            <p:cond delay="0"/>
+                                          </p:stCondLst>
+                                        </p:cTn>
+                                        <p:tgtEl>
+                                          <p:spTgt spid="10"/>
+                                        </p:tgtEl>
+                                        <p:attrNameLst>
+                                          <p:attrName>style.visibility</p:attrName>
+                                        </p:attrNameLst>
+                                      </p:cBhvr>
+                                      <p:to>
+                                        <p:strVal val="visible"/>
+                                      </p:to>
+                                    </p:set>
+                                  </p:childTnLst>
+                                </p:cTn>
+                              </p:par>
+                              <p:par>
+                                <p:cTn id="19" presetID="1" presetClass="entr" presetSubtype="0" fill="hold" grpId="0" nodeType="withEffect">
+                                  <p:stCondLst>
+                                    <p:cond delay="0"/>
+                                  </p:stCondLst>
+                                  <p:childTnLst>
+                                    <p:set>
+                                      <p:cBhvr>
+                                        <p:cTn id="20" dur="1" fill="hold">
+                                          <p:stCondLst>
+                                            <p:cond delay="0"/>
+                                          </p:stCondLst>
+                                        </p:cTn>
+                                        <p:tgtEl>
+                                          <p:spTgt spid="12"/>
+                                        </p:tgtEl>
+                                        <p:attrNameLst>
+                                          <p:attrName>style.visibility</p:attrName>
+                                        </p:attrNameLst>
+                                      </p:cBhvr>
+                                      <p:to>
+                                        <p:strVal val="visible"/>
+                                      </p:to>
+                                    </p:set>
+                                  </p:childTnLst>
+                                </p:cTn>
+                              </p:par>
+                              <p:par>
+                                <p:cTn id="21" presetID="1" presetClass="entr" presetSubtype="0" fill="hold" nodeType="withEffect">
+                                  <p:stCondLst>
+                                    <p:cond delay="0"/>
+                                  </p:stCondLst>
+                                  <p:childTnLst>
+                                    <p:set>
+                                      <p:cBhvr>
+                                        <p:cTn id="22" dur="1" fill="hold">
+                                          <p:stCondLst>
+                                            <p:cond delay="0"/>
+                                          </p:stCondLst>
+                                        </p:cTn>
+                                        <p:tgtEl>
+                                          <p:spTgt spid="11"/>
+                                        </p:tgtEl>
+                                        <p:attrNameLst>
+                                          <p:attrName>style.visibility</p:attrName>
+                                        </p:attrNameLst>
+                                      </p:cBhvr>
+                                      <p:to>
+                                        <p:strVal val="visible"/>
+                                      </p:to>
+                                    </p:set>
+                                  </p:childTnLst>
+                                </p:cTn>
+                              </p:par>
+                            </p:childTnLst>
+                          </p:cTn>
+                        </p:par>
+                      </p:childTnLst>
+                    </p:cTn>
+                  </p:par>
+                  <p:par>
+                    <p:cTn id="23" fill="hold">
+                      <p:stCondLst>
+                        <p:cond delay="indefinite"/>
+                      </p:stCondLst>
+                      <p:childTnLst>
+                        <p:par>
+                          <p:cTn id="24" fill="hold">
+                            <p:stCondLst>
+                              <p:cond delay="0"/>
+                            </p:stCondLst>
+                            <p:childTnLst>
+                              <p:par>
+                                <p:cTn id="25" presetID="1" presetClass="entr" presetSubtype="0" fill="hold" grpId="0" nodeType="clickEffect">
+                                  <p:stCondLst>
+                                    <p:cond delay="0"/>
+                                  </p:stCondLst>
+                                  <p:childTnLst>
+                                    <p:set>
+                                      <p:cBhvr>
+                                        <p:cTn id="26" dur="1" fill="hold">
+                                          <p:stCondLst>
+                                            <p:cond delay="0"/>
+                                          </p:stCondLst>
+                                        </p:cTn>
+                                        <p:tgtEl>
+                                          <p:spTgt spid="17"/>
+                                        </p:tgtEl>
+                                        <p:attrNameLst>
+                                          <p:attrName>style.visibility</p:attrName>
+                                        </p:attrNameLst>
+                                      </p:cBhvr>
+                                      <p:to>
+                                        <p:strVal val="visible"/>
+                                      </p:to>
+                                    </p:set>
+                                  </p:childTnLst>
+                                </p:cTn>
+                              </p:par>
+                              <p:par>
+                                <p:cTn id="27" presetID="1" presetClass="entr" presetSubtype="0" fill="hold" grpId="0" nodeType="withEffect">
+                                  <p:stCondLst>
+                                    <p:cond delay="0"/>
+                                  </p:stCondLst>
+                                  <p:childTnLst>
+                                    <p:set>
+                                      <p:cBhvr>
+                                        <p:cTn id="28" dur="1" fill="hold">
+                                          <p:stCondLst>
+                                            <p:cond delay="0"/>
+                                          </p:stCondLst>
+                                        </p:cTn>
+                                        <p:tgtEl>
+                                          <p:spTgt spid="14"/>
+                                        </p:tgtEl>
+                                        <p:attrNameLst>
+                                          <p:attrName>style.visibility</p:attrName>
+                                        </p:attrNameLst>
+                                      </p:cBhvr>
+                                      <p:to>
+                                        <p:strVal val="visible"/>
+                                      </p:to>
+                                    </p:set>
+                                  </p:childTnLst>
+                                </p:cTn>
+                              </p:par>
+                              <p:par>
+                                <p:cTn id="29" presetID="1" presetClass="entr" presetSubtype="0" fill="hold" grpId="0" nodeType="withEffect">
+                                  <p:stCondLst>
+                                    <p:cond delay="0"/>
+                                  </p:stCondLst>
+                                  <p:childTnLst>
+                                    <p:set>
+                                      <p:cBhvr>
+                                        <p:cTn id="30" dur="1" fill="hold">
+                                          <p:stCondLst>
+                                            <p:cond delay="0"/>
+                                          </p:stCondLst>
+                                        </p:cTn>
+                                        <p:tgtEl>
+                                          <p:spTgt spid="16"/>
+                                        </p:tgtEl>
+                                        <p:attrNameLst>
+                                          <p:attrName>style.visibility</p:attrName>
+                                        </p:attrNameLst>
+                                      </p:cBhvr>
+                                      <p:to>
+                                        <p:strVal val="visible"/>
+                                      </p:to>
+                                    </p:set>
+                                  </p:childTnLst>
+                                </p:cTn>
+                              </p:par>
+                              <p:par>
+                                <p:cTn id="31" presetID="1" presetClass="entr" presetSubtype="0" fill="hold" nodeType="withEffect">
+                                  <p:stCondLst>
+                                    <p:cond delay="0"/>
+                                  </p:stCondLst>
+                                  <p:childTnLst>
+                                    <p:set>
+                                      <p:cBhvr>
+                                        <p:cTn id="32" dur="1" fill="hold">
+                                          <p:stCondLst>
+                                            <p:cond delay="0"/>
+                                          </p:stCondLst>
+                                        </p:cTn>
+                                        <p:tgtEl>
+                                          <p:spTgt spid="15"/>
+                                        </p:tgtEl>
+                                        <p:attrNameLst>
+                                          <p:attrName>style.visibility</p:attrName>
+                                        </p:attrNameLst>
+                                      </p:cBhvr>
+                                      <p:to>
+                                        <p:strVal val="visible"/>
+                                      </p:to>
+                                    </p:set>
+                                  </p:childTnLst>
+                                </p:cTn>
+                              </p:par>
+                            </p:childTnLst>
+                          </p:cTn>
+                        </p:par>
+                      </p:childTnLst>
+                    </p:cTn>
+                  </p:par>
+                  <p:par>
+                    <p:cTn id="33" fill="hold">
+                      <p:stCondLst>
+                        <p:cond delay="indefinite"/>
+                      </p:stCondLst>
+                      <p:childTnLst>
+                        <p:par>
+                          <p:cTn id="34" fill="hold">
+                            <p:stCondLst>
+                              <p:cond delay="0"/>
+                            </p:stCondLst>
+                            <p:childTnLst>
+                              <p:par>
+                                <p:cTn id="35" presetID="1" presetClass="entr" presetSubtype="0" fill="hold" grpId="0" nodeType="clickEffect">
+                                  <p:stCondLst>
+                                    <p:cond delay="0"/>
+                                  </p:stCondLst>
+                                  <p:childTnLst>
+                                    <p:set>
+                                      <p:cBhvr>
+                                        <p:cTn id="36" dur="1" fill="hold">
+                                          <p:stCondLst>
+                                            <p:cond delay="0"/>
+                                          </p:stCondLst>
+                                        </p:cTn>
+                                        <p:tgtEl>
+                                          <p:spTgt spid="18"/>
+                                        </p:tgtEl>
+                                        <p:attrNameLst>
+                                          <p:attrName>style.visibility</p:attrName>
+                                        </p:attrNameLst>
+                                      </p:cBhvr>
+                                      <p:to>
+                                        <p:strVal val="visible"/>
+                                      </p:to>
+                                    </p:set>
+                                  </p:childTnLst>
+                                </p:cTn>
+                              </p:par>
+                              <p:par>
+                                <p:cTn id="37" presetID="1" presetClass="entr" presetSubtype="0" fill="hold" nodeType="withEffect">
+                                  <p:stCondLst>
+                                    <p:cond delay="0"/>
+                                  </p:stCondLst>
+                                  <p:childTnLst>
+                                    <p:set>
+                                      <p:cBhvr>
+                                        <p:cTn id="38" dur="1" fill="hold">
+                                          <p:stCondLst>
+                                            <p:cond delay="0"/>
+                                          </p:stCondLst>
+                                        </p:cTn>
+                                        <p:tgtEl>
+                                          <p:spTgt spid="19"/>
+                                        </p:tgtEl>
+                                        <p:attrNameLst>
+                                          <p:attrName>style.visibility</p:attrName>
+                                        </p:attrNameLst>
+                                      </p:cBhvr>
+                                      <p:to>
+                                        <p:strVal val="visible"/>
+                                      </p:to>
+                                    </p:set>
+                                  </p:childTnLst>
+                                </p:cTn>
+                              </p:par>
+                              <p:par>
+                                <p:cTn id="39" presetID="1" presetClass="entr" presetSubtype="0" fill="hold" grpId="0" nodeType="withEffect">
+                                  <p:stCondLst>
+                                    <p:cond delay="0"/>
+                                  </p:stCondLst>
+                                  <p:childTnLst>
+                                    <p:set>
+                                      <p:cBhvr>
+                                        <p:cTn id="40" dur="1" fill="hold">
+                                          <p:stCondLst>
+                                            <p:cond delay="0"/>
+                                          </p:stCondLst>
+                                        </p:cTn>
+                                        <p:tgtEl>
+                                          <p:spTgt spid="20"/>
+                                        </p:tgtEl>
+                                        <p:attrNameLst>
+                                          <p:attrName>style.visibility</p:attrName>
+                                        </p:attrNameLst>
+                                      </p:cBhvr>
+                                      <p:to>
+                                        <p:strVal val="visible"/>
+                                      </p:to>
+                                    </p:set>
+                                  </p:childTnLst>
+                                </p:cTn>
+                              </p:par>
+                              <p:par>
+                                <p:cTn id="41" presetID="1" presetClass="entr" presetSubtype="0" fill="hold" grpId="0" nodeType="withEffect">
+                                  <p:stCondLst>
+                                    <p:cond delay="0"/>
+                                  </p:stCondLst>
+                                  <p:childTnLst>
+                                    <p:set>
+                                      <p:cBhvr>
+                                        <p:cTn id="42" dur="1" fill="hold">
+                                          <p:stCondLst>
+                                            <p:cond delay="0"/>
+                                          </p:stCondLst>
+                                        </p:cTn>
+                                        <p:tgtEl>
+                                          <p:spTgt spid="21"/>
+                                        </p:tgtEl>
+                                        <p:attrNameLst>
+                                          <p:attrName>style.visibility</p:attrName>
+                                        </p:attrNameLst>
+                                      </p:cBhvr>
+                                      <p:to>
+                                        <p:strVal val="visible"/>
+                                      </p:to>
+                                    </p:set>
+                                  </p:childTnLst>
+                                </p:cTn>
+                              </p:par>
+                            </p:childTnLst>
+                          </p:cTn>
+                        </p:par>
+                      </p:childTnLst>
+                    </p:cTn>
+                  </p:par>
+                  <p:par>
+                    <p:cTn id="43" fill="hold">
+                      <p:stCondLst>
+                        <p:cond delay="indefinite"/>
+                      </p:stCondLst>
+                      <p:childTnLst>
+                        <p:par>
+                          <p:cTn id="44" fill="hold">
+                            <p:stCondLst>
+                              <p:cond delay="0"/>
+                            </p:stCondLst>
+                            <p:childTnLst>
+                              <p:par>
+                                <p:cTn id="45" presetID="1" presetClass="entr" presetSubtype="0" fill="hold" grpId="0" nodeType="clickEffect">
+                                  <p:stCondLst>
+                                    <p:cond delay="0"/>
+                                  </p:stCondLst>
+                                  <p:childTnLst>
+                                    <p:set>
+                                      <p:cBhvr>
+                                        <p:cTn id="46" dur="1" fill="hold">
+                                          <p:stCondLst>
+                                            <p:cond delay="0"/>
+                                          </p:stCondLst>
+                                        </p:cTn>
+                                        <p:tgtEl>
+                                          <p:spTgt spid="24"/>
+                                        </p:tgtEl>
+                                        <p:attrNameLst>
+                                          <p:attrName>style.visibility</p:attrName>
+                                        </p:attrNameLst>
+                                      </p:cBhvr>
+                                      <p:to>
+                                        <p:strVal val="visible"/>
+                                      </p:to>
+                                    </p:set>
+                                  </p:childTnLst>
+                                </p:cTn>
+                              </p:par>
+                              <p:par>
+                                <p:cTn id="47" presetID="1" presetClass="entr" presetSubtype="0" fill="hold" grpId="0" nodeType="withEffect">
+                                  <p:stCondLst>
+                                    <p:cond delay="0"/>
+                                  </p:stCondLst>
+                                  <p:childTnLst>
+                                    <p:set>
+                                      <p:cBhvr>
+                                        <p:cTn id="48" dur="1" fill="hold">
+                                          <p:stCondLst>
+                                            <p:cond delay="0"/>
+                                          </p:stCondLst>
+                                        </p:cTn>
+                                        <p:tgtEl>
+                                          <p:spTgt spid="25"/>
+                                        </p:tgtEl>
+                                        <p:attrNameLst>
+                                          <p:attrName>style.visibility</p:attrName>
+                                        </p:attrNameLst>
+                                      </p:cBhvr>
+                                      <p:to>
+                                        <p:strVal val="visible"/>
+                                      </p:to>
+                                    </p:set>
+                                  </p:childTnLst>
+                                </p:cTn>
+                              </p:par>
+                              <p:par>
+                                <p:cTn id="49" presetID="1" presetClass="entr" presetSubtype="0" fill="hold" nodeType="withEffect">
+                                  <p:stCondLst>
+                                    <p:cond delay="0"/>
+                                  </p:stCondLst>
+                                  <p:childTnLst>
+                                    <p:set>
+                                      <p:cBhvr>
+                                        <p:cTn id="50" dur="1" fill="hold">
+                                          <p:stCondLst>
+                                            <p:cond delay="0"/>
+                                          </p:stCondLst>
+                                        </p:cTn>
+                                        <p:tgtEl>
+                                          <p:spTgt spid="23"/>
+                                        </p:tgtEl>
+                                        <p:attrNameLst>
+                                          <p:attrName>style.visibility</p:attrName>
+                                        </p:attrNameLst>
+                                      </p:cBhvr>
+                                      <p:to>
+                                        <p:strVal val="visible"/>
+                                      </p:to>
+                                    </p:set>
+                                  </p:childTnLst>
+                                </p:cTn>
+                              </p:par>
+                              <p:par>
+                                <p:cTn id="51" presetID="1" presetClass="entr" presetSubtype="0" fill="hold" grpId="0" nodeType="withEffect">
+                                  <p:stCondLst>
+                                    <p:cond delay="0"/>
+                                  </p:stCondLst>
+                                  <p:childTnLst>
+                                    <p:set>
+                                      <p:cBhvr>
+                                        <p:cTn id="52" dur="1" fill="hold">
+                                          <p:stCondLst>
+                                            <p:cond delay="0"/>
+                                          </p:stCondLst>
+                                        </p:cTn>
+                                        <p:tgtEl>
+                                          <p:spTgt spid="22"/>
+                                        </p:tgtEl>
+                                        <p:attrNameLst>
+                                          <p:attrName>style.visibility</p:attrName>
+                                        </p:attrNameLst>
+                                      </p:cBhvr>
+                                      <p:to>
+                                        <p:strVal val="visible"/>
+                                      </p:to>
+                                    </p:set>
+                                  </p:childTnLst>
+                                </p:cTn>
+                              </p:par>
+                            </p:childTnLst>
+                          </p:cTn>
+                        </p:par>
+                      </p:childTnLst>
+                    </p:cTn>
+                  </p:par>
+                  <p:par>
+                    <p:cTn id="53" fill="hold">
+                      <p:stCondLst>
+                        <p:cond delay="indefinite"/>
+                      </p:stCondLst>
+                      <p:childTnLst>
+                        <p:par>
+                          <p:cTn id="54" fill="hold">
+                            <p:stCondLst>
+                              <p:cond delay="0"/>
+                            </p:stCondLst>
+                            <p:childTnLst>
+                              <p:par>
+                                <p:cTn id="55" presetID="1" presetClass="entr" presetSubtype="0" fill="hold" nodeType="clickEffect">
+                                  <p:stCondLst>
+                                    <p:cond delay="0"/>
+                                  </p:stCondLst>
+                                  <p:childTnLst>
+                                    <p:set>
+                                      <p:cBhvr>
+                                        <p:cTn id="56" dur="1" fill="hold">
+                                          <p:stCondLst>
+                                            <p:cond delay="0"/>
+                                          </p:stCondLst>
+                                        </p:cTn>
+                                        <p:tgtEl>
+                                          <p:spTgt spid="27"/>
+                                        </p:tgtEl>
+                                        <p:attrNameLst>
+                                          <p:attrName>style.visibility</p:attrName>
+                                        </p:attrNameLst>
+                                      </p:cBhvr>
+                                      <p:to>
+                                        <p:strVal val="visible"/>
+                                      </p:to>
+                                    </p:set>
+                                  </p:childTnLst>
+                                </p:cTn>
+                              </p:par>
+                              <p:par>
+                                <p:cTn id="57" presetID="1" presetClass="entr" presetSubtype="0" fill="hold" grpId="0" nodeType="withEffect">
+                                  <p:stCondLst>
+                                    <p:cond delay="0"/>
+                                  </p:stCondLst>
+                                  <p:childTnLst>
+                                    <p:set>
+                                      <p:cBhvr>
+                                        <p:cTn id="58" dur="1" fill="hold">
+                                          <p:stCondLst>
+                                            <p:cond delay="0"/>
+                                          </p:stCondLst>
+                                        </p:cTn>
+                                        <p:tgtEl>
+                                          <p:spTgt spid="29"/>
+                                        </p:tgtEl>
+                                        <p:attrNameLst>
+                                          <p:attrName>style.visibility</p:attrName>
+                                        </p:attrNameLst>
+                                      </p:cBhvr>
+                                      <p:to>
+                                        <p:strVal val="visible"/>
+                                      </p:to>
+                                    </p:set>
+                                  </p:childTnLst>
+                                </p:cTn>
+                              </p:par>
+                              <p:par>
+                                <p:cTn id="59" presetID="1" presetClass="entr" presetSubtype="0" fill="hold" grpId="0" nodeType="withEffect">
+                                  <p:stCondLst>
+                                    <p:cond delay="0"/>
+                                  </p:stCondLst>
+                                  <p:childTnLst>
+                                    <p:set>
+                                      <p:cBhvr>
+                                        <p:cTn id="60" dur="1" fill="hold">
+                                          <p:stCondLst>
+                                            <p:cond delay="0"/>
+                                          </p:stCondLst>
+                                        </p:cTn>
+                                        <p:tgtEl>
+                                          <p:spTgt spid="28"/>
+                                        </p:tgtEl>
+                                        <p:attrNameLst>
+                                          <p:attrName>style.visibility</p:attrName>
+                                        </p:attrNameLst>
+                                      </p:cBhvr>
+                                      <p:to>
+                                        <p:strVal val="visible"/>
+                                      </p:to>
+                                    </p:set>
+                                  </p:childTnLst>
+                                </p:cTn>
+                              </p:par>
+                              <p:par>
+                                <p:cTn id="61" presetID="1" presetClass="entr" presetSubtype="0" fill="hold" grpId="0" nodeType="withEffect">
+                                  <p:stCondLst>
+                                    <p:cond delay="0"/>
+                                  </p:stCondLst>
+                                  <p:childTnLst>
+                                    <p:set>
+                                      <p:cBhvr>
+                                        <p:cTn id="62" dur="1" fill="hold">
+                                          <p:stCondLst>
+                                            <p:cond delay="0"/>
+                                          </p:stCondLst>
+                                        </p:cTn>
+                                        <p:tgtEl>
+                                          <p:spTgt spid="26"/>
+                                        </p:tgtEl>
+                                        <p:attrNameLst>
+                                          <p:attrName>style.visibility</p:attrName>
+                                        </p:attrNameLst>
+                                      </p:cBhvr>
+                                      <p:to>
+                                        <p:strVal val="visible"/>
+                                      </p:to>
+                                    </p:set>
+                                  </p:childTnLst>
+                                </p:cTn>
+                              </p:par>
+                            </p:childTnLst>
+                          </p:cTn>
+                        </p:par>
+                      </p:childTnLst>
+                    </p:cTn>
+                  </p:par>
+                </p:childTnLst>
+              </p:cTn>
+              <p:prevCondLst>
+                <p:cond evt="onPrev" delay="0">
+                  <p:tgtEl>
+                    <p:sldTgt/>
+                  </p:tgtEl>
+                </p:cond>
+              </p:prevCondLst>
+              <p:nextCondLst>
+                <p:cond evt="onNext" delay="0">
+                  <p:tgtEl>
+                    <p:sldTgt/>
+                  </p:tgtEl>
+                </p:cond>
+              </p:nextCondLst>
+            </p:seq>
+          </p:childTnLst>
+        </p:cTn>
+      </p:par>
+    </p:tnLst>
+    <p:bldLst>
+      <p:bldP spid="6" grpId="0" animBg="1"/>
+      <p:bldP spid="8" grpId="0"/>
+      <p:bldP spid="9" grpId="0"/>
+      <p:bldP spid="10" grpId="0" animBg="1"/>
+      <p:bldP spid="12" grpId="0"/>
+      <p:bldP spid="13" grpId="0"/>
+      <p:bldP spid="14" grpId="0" animBg="1"/>
+      <p:bldP spid="16" grpId="0"/>
+      <p:bldP spid="17" grpId="0"/>
+      <p:bldP spid="18" grpId="0" animBg="1"/>
+      <p:bldP spid="20" grpId="0"/>
+      <p:bldP spid="21" grpId="0"/>
+      <p:bldP spid="22" grpId="0" animBg="1"/>
+      <p:bldP spid="24" grpId="0"/>
+      <p:bldP spid="25" grpId="0"/>
+      <p:bldP spid="26" grpId="0" animBg="1"/>
+      <p:bldP spid="28" grpId="0"/>
+      <p:bldP spid="29" grpId="0"/>
+    </p:bldLst>
+  </p:timing>
 </p:sld>
 </file>
 
@@ -19508,4 +20558,319 @@
   </a:objectDefaults>
   <a:extraClrSchemeLst/>
 </a:theme>
+</file>
+
+<file path=ppt/theme/theme2.xml><?xml version="1.0" encoding="utf-8"?>
+<a:theme xmlns:a="http://schemas.openxmlformats.org/drawingml/2006/main" name="Office Theme">
+  <a:themeElements>
+    <a:clrScheme name="Office">
+      <a:dk1>
+        <a:sysClr val="windowText" lastClr="000000"/>
+      </a:dk1>
+      <a:lt1>
+        <a:sysClr val="window" lastClr="FFFFFF"/>
+      </a:lt1>
+      <a:dk2>
+        <a:srgbClr val="0E2841"/>
+      </a:dk2>
+      <a:lt2>
+        <a:srgbClr val="E8E8E8"/>
+      </a:lt2>
+      <a:accent1>
+        <a:srgbClr val="156082"/>
+      </a:accent1>
+      <a:accent2>
+        <a:srgbClr val="E97132"/>
+      </a:accent2>
+      <a:accent3>
+        <a:srgbClr val="196B24"/>
+      </a:accent3>
+      <a:accent4>
+        <a:srgbClr val="0F9ED5"/>
+      </a:accent4>
+      <a:accent5>
+        <a:srgbClr val="A02B93"/>
+      </a:accent5>
+      <a:accent6>
+        <a:srgbClr val="4EA72E"/>
+      </a:accent6>
+      <a:hlink>
+        <a:srgbClr val="467886"/>
+      </a:hlink>
+      <a:folHlink>
+        <a:srgbClr val="96607D"/>
+      </a:folHlink>
+    </a:clrScheme>
+    <a:fontScheme name="Office">
+      <a:majorFont>
+        <a:latin typeface="Aptos Display" panose="02110004020202020204"/>
+        <a:ea typeface=""/>
+        <a:cs typeface=""/>
+        <a:font script="Jpan" typeface="游ゴシック Light"/>
+        <a:font script="Hang" typeface="맑은 고딕"/>
+        <a:font script="Hans" typeface="等线 Light"/>
+        <a:font script="Hant" typeface="新細明體"/>
+        <a:font script="Arab" typeface="Times New Roman"/>
+        <a:font script="Hebr" typeface="Times New Roman"/>
+        <a:font script="Thai" typeface="Angsana New"/>
+        <a:font script="Ethi" typeface="Nyala"/>
+        <a:font script="Beng" typeface="Vrinda"/>
+        <a:font script="Gujr" typeface="Shruti"/>
+        <a:font script="Khmr" typeface="MoolBoran"/>
+        <a:font script="Knda" typeface="Tunga"/>
+        <a:font script="Guru" typeface="Raavi"/>
+        <a:font script="Cans" typeface="Euphemia"/>
+        <a:font script="Cher" typeface="Plantagenet Cherokee"/>
+        <a:font script="Yiii" typeface="Microsoft Yi Baiti"/>
+        <a:font script="Tibt" typeface="Microsoft Himalaya"/>
+        <a:font script="Thaa" typeface="MV Boli"/>
+        <a:font script="Deva" typeface="Mangal"/>
+        <a:font script="Telu" typeface="Gautami"/>
+        <a:font script="Taml" typeface="Latha"/>
+        <a:font script="Syrc" typeface="Estrangelo Edessa"/>
+        <a:font script="Orya" typeface="Kalinga"/>
+        <a:font script="Mlym" typeface="Kartika"/>
+        <a:font script="Laoo" typeface="DokChampa"/>
+        <a:font script="Sinh" typeface="Iskoola Pota"/>
+        <a:font script="Mong" typeface="Mongolian Baiti"/>
+        <a:font script="Viet" typeface="Times New Roman"/>
+        <a:font script="Uigh" typeface="Microsoft Uighur"/>
+        <a:font script="Geor" typeface="Sylfaen"/>
+        <a:font script="Armn" typeface="Arial"/>
+        <a:font script="Bugi" typeface="Leelawadee UI"/>
+        <a:font script="Bopo" typeface="Microsoft JhengHei"/>
+        <a:font script="Java" typeface="Javanese Text"/>
+        <a:font script="Lisu" typeface="Segoe UI"/>
+        <a:font script="Mymr" typeface="Myanmar Text"/>
+        <a:font script="Nkoo" typeface="Ebrima"/>
+        <a:font script="Olck" typeface="Nirmala UI"/>
+        <a:font script="Osma" typeface="Ebrima"/>
+        <a:font script="Phag" typeface="Phagspa"/>
+        <a:font script="Syrn" typeface="Estrangelo Edessa"/>
+        <a:font script="Syrj" typeface="Estrangelo Edessa"/>
+        <a:font script="Syre" typeface="Estrangelo Edessa"/>
+        <a:font script="Sora" typeface="Nirmala UI"/>
+        <a:font script="Tale" typeface="Microsoft Tai Le"/>
+        <a:font script="Talu" typeface="Microsoft New Tai Lue"/>
+        <a:font script="Tfng" typeface="Ebrima"/>
+      </a:majorFont>
+      <a:minorFont>
+        <a:latin typeface="Aptos" panose="02110004020202020204"/>
+        <a:ea typeface=""/>
+        <a:cs typeface=""/>
+        <a:font script="Jpan" typeface="游ゴシック"/>
+        <a:font script="Hang" typeface="맑은 고딕"/>
+        <a:font script="Hans" typeface="等线"/>
+        <a:font script="Hant" typeface="新細明體"/>
+        <a:font script="Arab" typeface="Arial"/>
+        <a:font script="Hebr" typeface="Arial"/>
+        <a:font script="Thai" typeface="Cordia New"/>
+        <a:font script="Ethi" typeface="Nyala"/>
+        <a:font script="Beng" typeface="Vrinda"/>
+        <a:font script="Gujr" typeface="Shruti"/>
+        <a:font script="Khmr" typeface="DaunPenh"/>
+        <a:font script="Knda" typeface="Tunga"/>
+        <a:font script="Guru" typeface="Raavi"/>
+        <a:font script="Cans" typeface="Euphemia"/>
+        <a:font script="Cher" typeface="Plantagenet Cherokee"/>
+        <a:font script="Yiii" typeface="Microsoft Yi Baiti"/>
+        <a:font script="Tibt" typeface="Microsoft Himalaya"/>
+        <a:font script="Thaa" typeface="MV Boli"/>
+        <a:font script="Deva" typeface="Mangal"/>
+        <a:font script="Telu" typeface="Gautami"/>
+        <a:font script="Taml" typeface="Latha"/>
+        <a:font script="Syrc" typeface="Estrangelo Edessa"/>
+        <a:font script="Orya" typeface="Kalinga"/>
+        <a:font script="Mlym" typeface="Kartika"/>
+        <a:font script="Laoo" typeface="DokChampa"/>
+        <a:font script="Sinh" typeface="Iskoola Pota"/>
+        <a:font script="Mong" typeface="Mongolian Baiti"/>
+        <a:font script="Viet" typeface="Arial"/>
+        <a:font script="Uigh" typeface="Microsoft Uighur"/>
+        <a:font script="Geor" typeface="Sylfaen"/>
+        <a:font script="Armn" typeface="Arial"/>
+        <a:font script="Bugi" typeface="Leelawadee UI"/>
+        <a:font script="Bopo" typeface="Microsoft JhengHei"/>
+        <a:font script="Java" typeface="Javanese Text"/>
+        <a:font script="Lisu" typeface="Segoe UI"/>
+        <a:font script="Mymr" typeface="Myanmar Text"/>
+        <a:font script="Nkoo" typeface="Ebrima"/>
+        <a:font script="Olck" typeface="Nirmala UI"/>
+        <a:font script="Osma" typeface="Ebrima"/>
+        <a:font script="Phag" typeface="Phagspa"/>
+        <a:font script="Syrn" typeface="Estrangelo Edessa"/>
+        <a:font script="Syrj" typeface="Estrangelo Edessa"/>
+        <a:font script="Syre" typeface="Estrangelo Edessa"/>
+        <a:font script="Sora" typeface="Nirmala UI"/>
+        <a:font script="Tale" typeface="Microsoft Tai Le"/>
+        <a:font script="Talu" typeface="Microsoft New Tai Lue"/>
+        <a:font script="Tfng" typeface="Ebrima"/>
+      </a:minorFont>
+    </a:fontScheme>
+    <a:fmtScheme name="Office">
+      <a:fillStyleLst>
+        <a:solidFill>
+          <a:schemeClr val="phClr"/>
+        </a:solidFill>
+        <a:gradFill rotWithShape="1">
+          <a:gsLst>
+            <a:gs pos="0">
+              <a:schemeClr val="phClr">
+                <a:lumMod val="110000"/>
+                <a:satMod val="105000"/>
+                <a:tint val="67000"/>
+              </a:schemeClr>
+            </a:gs>
+            <a:gs pos="50000">
+              <a:schemeClr val="phClr">
+                <a:lumMod val="105000"/>
+                <a:satMod val="103000"/>
+                <a:tint val="73000"/>
+              </a:schemeClr>
+            </a:gs>
+            <a:gs pos="100000">
+              <a:schemeClr val="phClr">
+                <a:lumMod val="105000"/>
+                <a:satMod val="109000"/>
+                <a:tint val="81000"/>
+              </a:schemeClr>
+            </a:gs>
+          </a:gsLst>
+          <a:lin ang="5400000" scaled="0"/>
+        </a:gradFill>
+        <a:gradFill rotWithShape="1">
+          <a:gsLst>
+            <a:gs pos="0">
+              <a:schemeClr val="phClr">
+                <a:satMod val="103000"/>
+                <a:lumMod val="102000"/>
+                <a:tint val="94000"/>
+              </a:schemeClr>
+            </a:gs>
+            <a:gs pos="50000">
+              <a:schemeClr val="phClr">
+                <a:satMod val="110000"/>
+                <a:lumMod val="100000"/>
+                <a:shade val="100000"/>
+              </a:schemeClr>
+            </a:gs>
+            <a:gs pos="100000">
+              <a:schemeClr val="phClr">
+                <a:lumMod val="99000"/>
+                <a:satMod val="120000"/>
+                <a:shade val="78000"/>
+              </a:schemeClr>
+            </a:gs>
+          </a:gsLst>
+          <a:lin ang="5400000" scaled="0"/>
+        </a:gradFill>
+      </a:fillStyleLst>
+      <a:lnStyleLst>
+        <a:ln w="12700" cap="flat" cmpd="sng" algn="ctr">
+          <a:solidFill>
+            <a:schemeClr val="phClr"/>
+          </a:solidFill>
+          <a:prstDash val="solid"/>
+          <a:miter lim="800000"/>
+        </a:ln>
+        <a:ln w="19050" cap="flat" cmpd="sng" algn="ctr">
+          <a:solidFill>
+            <a:schemeClr val="phClr"/>
+          </a:solidFill>
+          <a:prstDash val="solid"/>
+          <a:miter lim="800000"/>
+        </a:ln>
+        <a:ln w="25400" cap="flat" cmpd="sng" algn="ctr">
+          <a:solidFill>
+            <a:schemeClr val="phClr"/>
+          </a:solidFill>
+          <a:prstDash val="solid"/>
+          <a:miter lim="800000"/>
+        </a:ln>
+      </a:lnStyleLst>
+      <a:effectStyleLst>
+        <a:effectStyle>
+          <a:effectLst/>
+        </a:effectStyle>
+        <a:effectStyle>
+          <a:effectLst/>
+        </a:effectStyle>
+        <a:effectStyle>
+          <a:effectLst>
+            <a:outerShdw blurRad="57150" dist="19050" dir="5400000" algn="ctr" rotWithShape="0">
+              <a:srgbClr val="000000">
+                <a:alpha val="63000"/>
+              </a:srgbClr>
+            </a:outerShdw>
+          </a:effectLst>
+        </a:effectStyle>
+      </a:effectStyleLst>
+      <a:bgFillStyleLst>
+        <a:solidFill>
+          <a:schemeClr val="phClr"/>
+        </a:solidFill>
+        <a:solidFill>
+          <a:schemeClr val="phClr">
+            <a:tint val="95000"/>
+            <a:satMod val="170000"/>
+          </a:schemeClr>
+        </a:solidFill>
+        <a:gradFill rotWithShape="1">
+          <a:gsLst>
+            <a:gs pos="0">
+              <a:schemeClr val="phClr">
+                <a:tint val="93000"/>
+                <a:satMod val="150000"/>
+                <a:shade val="98000"/>
+                <a:lumMod val="102000"/>
+              </a:schemeClr>
+            </a:gs>
+            <a:gs pos="50000">
+              <a:schemeClr val="phClr">
+                <a:tint val="98000"/>
+                <a:satMod val="130000"/>
+                <a:shade val="90000"/>
+                <a:lumMod val="103000"/>
+              </a:schemeClr>
+            </a:gs>
+            <a:gs pos="100000">
+              <a:schemeClr val="phClr">
+                <a:shade val="63000"/>
+                <a:satMod val="120000"/>
+              </a:schemeClr>
+            </a:gs>
+          </a:gsLst>
+          <a:lin ang="5400000" scaled="0"/>
+        </a:gradFill>
+      </a:bgFillStyleLst>
+    </a:fmtScheme>
+  </a:themeElements>
+  <a:objectDefaults>
+    <a:lnDef>
+      <a:spPr/>
+      <a:bodyPr/>
+      <a:lstStyle/>
+      <a:style>
+        <a:lnRef idx="2">
+          <a:schemeClr val="accent1"/>
+        </a:lnRef>
+        <a:fillRef idx="0">
+          <a:schemeClr val="accent1"/>
+        </a:fillRef>
+        <a:effectRef idx="1">
+          <a:schemeClr val="accent1"/>
+        </a:effectRef>
+        <a:fontRef idx="minor">
+          <a:schemeClr val="tx1"/>
+        </a:fontRef>
+      </a:style>
+    </a:lnDef>
+  </a:objectDefaults>
+  <a:extraClrSchemeLst/>
+  <a:extLst>
+    <a:ext uri="{05A4C25C-085E-4340-85A3-A5531E510DB2}">
+      <thm15:themeFamily xmlns:thm15="http://schemas.microsoft.com/office/thememl/2012/main" name="Office Theme" id="{2E142A2C-CD16-42D6-873A-C26D2A0506FA}" vid="{1BDDFF52-6CD6-40A5-AB3C-68EB2F1E4D0A}"/>
+    </a:ext>
+  </a:extLst>
+</a:theme>
 </file>
</xml_diff>